<commit_message>
Fix v2 relay completion and ground final recommendations
</commit_message>
<xml_diff>
--- a/submission/v2/slides.pptx
+++ b/submission/v2/slides.pptx
@@ -2,17 +2,17 @@
 <file path=ppt/presentation.xml><?xml version="1.0" encoding="utf-8"?>
 <p:presentation xmlns:p="http://schemas.openxmlformats.org/presentationml/2006/main">
   <p:sldMasterIdLst>
-    <p:sldMasterId xmlns:r="http://schemas.openxmlformats.org/officeDocument/2006/relationships" id="2147483648" r:id="R549124e2bcf9477f"/>
+    <p:sldMasterId xmlns:r="http://schemas.openxmlformats.org/officeDocument/2006/relationships" id="2147483648" r:id="R1732f969247142ba"/>
   </p:sldMasterIdLst>
   <p:notesMasterIdLst>
-    <p:notesMasterId xmlns:r="http://schemas.openxmlformats.org/officeDocument/2006/relationships" r:id="R83d1ad96d6dc40d8"/>
+    <p:notesMasterId xmlns:r="http://schemas.openxmlformats.org/officeDocument/2006/relationships" r:id="R75f1cff8defa483f"/>
   </p:notesMasterIdLst>
   <p:sldIdLst>
-    <p:sldId xmlns:r="http://schemas.openxmlformats.org/officeDocument/2006/relationships" id="256" r:id="R745151d48cbc403e"/>
-    <p:sldId xmlns:r="http://schemas.openxmlformats.org/officeDocument/2006/relationships" id="257" r:id="R24d7977ee0fe445d"/>
-    <p:sldId xmlns:r="http://schemas.openxmlformats.org/officeDocument/2006/relationships" id="258" r:id="Ra599c2b8156547b8"/>
-    <p:sldId xmlns:r="http://schemas.openxmlformats.org/officeDocument/2006/relationships" id="259" r:id="R221a1c9b890a4f71"/>
-    <p:sldId xmlns:r="http://schemas.openxmlformats.org/officeDocument/2006/relationships" id="260" r:id="Rab4c351c17b24cc3"/>
+    <p:sldId xmlns:r="http://schemas.openxmlformats.org/officeDocument/2006/relationships" id="256" r:id="R79c6a600a72947d1"/>
+    <p:sldId xmlns:r="http://schemas.openxmlformats.org/officeDocument/2006/relationships" id="257" r:id="R97d35868662d4bde"/>
+    <p:sldId xmlns:r="http://schemas.openxmlformats.org/officeDocument/2006/relationships" id="258" r:id="Rac3d6698052d4e32"/>
+    <p:sldId xmlns:r="http://schemas.openxmlformats.org/officeDocument/2006/relationships" id="259" r:id="R5f840bbd5bf347ac"/>
+    <p:sldId xmlns:r="http://schemas.openxmlformats.org/officeDocument/2006/relationships" id="260" r:id="R546dc1a600394804"/>
   </p:sldIdLst>
   <p:sldSz cx="12192000" cy="6858000"/>
   <p:notesSz cx="6858000" cy="9144000"/>
@@ -601,7 +601,7 @@
           </a:p>
           <a:p xmlns:a="http://schemas.openxmlformats.org/drawingml/2006/main">
             <a:r>
-              <a:t>0:55–2:00. Open a separate business tab on the same laptop. It must remain inactive before customer authorization. Accept only when incoming. Use fictional customer details and business answers. Choose an unknown customer detail based on the actual interview, rather than assuming prior-visit status is unknown. If API credit is still blocked, show the explicit blocker and do not present synthetic fixtures as a live run.</a:t>
+              <a:t>0:55–2:00. Open a separate business tab on the same laptop. It must remain inactive before customer authorization. Accept only when incoming. Use fictional customer details and business answers. Choose an unknown customer detail based on the actual interview, rather than assuming prior-visit status is unknown. The third actual rehearsal captured four business answers and a readback, but confirmation reset the answers and the teammate disconnected. Unknown-detail relay and a normal completed call remain unverified. Demonstrate these steps only if a new real run actually reaches them.</a:t>
             </a:r>
           </a:p>
         </p:txBody>
@@ -676,7 +676,7 @@
           </a:p>
           <a:p xmlns:a="http://schemas.openxmlformats.org/drawingml/2006/main">
             <a:r>
-              <a:t>2:00–2:30. Evidence source: artifacts/v2/customer-ui-check.json and the integration checkpoint recorded in verification.md. Browser checks use mocked API routes, not real models or speech. State completion rules are an implementation boundary, not proof of a live successful call.</a:t>
+              <a:t>2:00–2:30. The current code checkpoint has 57 local tests, 17 local HTTP checks, 20 mocked customer browser checks, and 11 mocked business browser checks. These are different evidence classes. The third real laptop microphone run captured four actual Korean business answers and an assistant readback, including qualified cost uncertainty. Business confirmation incorrectly reset the resolved state; the human disconnected. Korean audibility was human-confirmed in the first attempt only. Unknown-detail relay was not exercised in the third attempt. Later readback fixes require another live rehearsal. Real Russian and Chinese interviews were exercised, but Korean question fidelity and unsupported first-visit wording remain limited. Sources: artifacts/v2/live-native-rehearsal-third-attempt.json; artifacts/v2/live-native-third-attempt-audit.json; artifacts/v2/customer-ui-check.json; docs/v2-verification.md. These local evidence files are not raw material for the official upload.</a:t>
             </a:r>
           </a:p>
         </p:txBody>
@@ -819,7 +819,7 @@
   </p:cSld>
   <p:clrMap bg1="lt1" tx1="dk1" bg2="lt2" tx2="dk2" accent1="accent1" accent2="accent2" accent3="accent3" accent4="accent4" accent5="accent5" accent6="accent6" hlink="hlink" folHlink="folHlink"/>
   <p:sldLayoutIdLst>
-    <p:sldLayoutId xmlns:r="http://schemas.openxmlformats.org/officeDocument/2006/relationships" id="2147483649" r:id="Rc2fb969887884006"/>
+    <p:sldLayoutId xmlns:r="http://schemas.openxmlformats.org/officeDocument/2006/relationships" id="2147483649" r:id="R0e273f56b4ea4acb"/>
   </p:sldLayoutIdLst>
   <p:txStyles>
     <p:titleStyle>
@@ -1370,7 +1370,7 @@
           <p:cNvPr id="7" name="">
             <a:extLst xmlns:a="http://schemas.openxmlformats.org/drawingml/2006/main">
               <a:ext uri="{FF2B5EF4-FFF2-40B4-BE49-F238E27FC236}">
-                <a16:creationId xmlns:a16="http://schemas.microsoft.com/office/drawing/2014/main" id="{974A1FC5-03AD-4A20-8B47-C161F596F850}"/>
+                <a16:creationId xmlns:a16="http://schemas.microsoft.com/office/drawing/2014/main" id="{0B10F6D8-A84C-4E3E-9055-99564B9060C2}"/>
               </a:ext>
             </a:extLst>
           </p:cNvPr>
@@ -1427,7 +1427,7 @@
           <p:cNvPr id="2" name="">
             <a:extLst xmlns:a="http://schemas.openxmlformats.org/drawingml/2006/main">
               <a:ext uri="{FF2B5EF4-FFF2-40B4-BE49-F238E27FC236}">
-                <a16:creationId xmlns:a16="http://schemas.microsoft.com/office/drawing/2014/main" id="{1522E35E-2906-4445-BCD5-1592AB4136FB}"/>
+                <a16:creationId xmlns:a16="http://schemas.microsoft.com/office/drawing/2014/main" id="{DC2A8840-16A9-4379-B089-AA3496F3EF92}"/>
               </a:ext>
             </a:extLst>
           </p:cNvPr>
@@ -1484,7 +1484,7 @@
           <p:cNvPr id="3" name="">
             <a:extLst xmlns:a="http://schemas.openxmlformats.org/drawingml/2006/main">
               <a:ext uri="{FF2B5EF4-FFF2-40B4-BE49-F238E27FC236}">
-                <a16:creationId xmlns:a16="http://schemas.microsoft.com/office/drawing/2014/main" id="{B0377C15-5E5A-4BC2-A727-527F9538B442}"/>
+                <a16:creationId xmlns:a16="http://schemas.microsoft.com/office/drawing/2014/main" id="{4D120FD0-7B08-45F1-B83F-12441D5FF386}"/>
               </a:ext>
             </a:extLst>
           </p:cNvPr>
@@ -1541,7 +1541,7 @@
           <p:cNvPr id="4" name="">
             <a:extLst xmlns:a="http://schemas.openxmlformats.org/drawingml/2006/main">
               <a:ext uri="{FF2B5EF4-FFF2-40B4-BE49-F238E27FC236}">
-                <a16:creationId xmlns:a16="http://schemas.microsoft.com/office/drawing/2014/main" id="{C18226A6-FE0B-4AF0-98E9-E83C1D874EA3}"/>
+                <a16:creationId xmlns:a16="http://schemas.microsoft.com/office/drawing/2014/main" id="{B55FF9D0-B6FA-457B-B997-144F92834DC0}"/>
               </a:ext>
             </a:extLst>
           </p:cNvPr>
@@ -1621,7 +1621,7 @@
           <p:cNvPr id="5" name="">
             <a:extLst xmlns:a="http://schemas.openxmlformats.org/drawingml/2006/main">
               <a:ext uri="{FF2B5EF4-FFF2-40B4-BE49-F238E27FC236}">
-                <a16:creationId xmlns:a16="http://schemas.microsoft.com/office/drawing/2014/main" id="{F8A6AD0E-6229-4598-B3B8-10F9493BDAD6}"/>
+                <a16:creationId xmlns:a16="http://schemas.microsoft.com/office/drawing/2014/main" id="{A55C45B0-788B-47A9-95D6-41FD1EB0AD05}"/>
               </a:ext>
             </a:extLst>
           </p:cNvPr>
@@ -1701,7 +1701,7 @@
           <p:cNvPr id="6" name="">
             <a:extLst xmlns:a="http://schemas.openxmlformats.org/drawingml/2006/main">
               <a:ext uri="{FF2B5EF4-FFF2-40B4-BE49-F238E27FC236}">
-                <a16:creationId xmlns:a16="http://schemas.microsoft.com/office/drawing/2014/main" id="{F770A8C9-BDA9-41E5-8846-8719E55C9A42}"/>
+                <a16:creationId xmlns:a16="http://schemas.microsoft.com/office/drawing/2014/main" id="{FA3C3B6E-1613-4D2D-82E2-035E5A01D9F9}"/>
               </a:ext>
             </a:extLst>
           </p:cNvPr>
@@ -1779,7 +1779,7 @@
     </p:spTree>
     <p:extLst>
       <p:ext uri="{BB962C8B-B14F-4D97-AF65-F5344CB8AC3E}">
-        <p14:creationId xmlns:p14="http://schemas.microsoft.com/office/powerpoint/2010/main" val="986330405"/>
+        <p14:creationId xmlns:p14="http://schemas.microsoft.com/office/powerpoint/2010/main" val="151634298"/>
       </p:ext>
     </p:extLst>
   </p:cSld>
@@ -1810,7 +1810,7 @@
           <p:cNvPr id="19" name="">
             <a:extLst xmlns:a="http://schemas.openxmlformats.org/drawingml/2006/main">
               <a:ext uri="{FF2B5EF4-FFF2-40B4-BE49-F238E27FC236}">
-                <a16:creationId xmlns:a16="http://schemas.microsoft.com/office/drawing/2014/main" id="{958C337D-9AF3-4E31-9DEC-666336AA9934}"/>
+                <a16:creationId xmlns:a16="http://schemas.microsoft.com/office/drawing/2014/main" id="{EE13DAF3-E77B-46F2-B59C-B37F6CF39C3C}"/>
               </a:ext>
             </a:extLst>
           </p:cNvPr>
@@ -1867,7 +1867,7 @@
           <p:cNvPr id="2" name="">
             <a:extLst xmlns:a="http://schemas.openxmlformats.org/drawingml/2006/main">
               <a:ext uri="{FF2B5EF4-FFF2-40B4-BE49-F238E27FC236}">
-                <a16:creationId xmlns:a16="http://schemas.microsoft.com/office/drawing/2014/main" id="{55728CC8-F247-4A8D-831C-6403B44D8749}"/>
+                <a16:creationId xmlns:a16="http://schemas.microsoft.com/office/drawing/2014/main" id="{581FB833-2D61-4C91-9684-2BFBCF0924EA}"/>
               </a:ext>
             </a:extLst>
           </p:cNvPr>
@@ -1924,7 +1924,7 @@
           <p:cNvPr id="3" name="">
             <a:extLst xmlns:a="http://schemas.openxmlformats.org/drawingml/2006/main">
               <a:ext uri="{FF2B5EF4-FFF2-40B4-BE49-F238E27FC236}">
-                <a16:creationId xmlns:a16="http://schemas.microsoft.com/office/drawing/2014/main" id="{0FD9FD56-395B-419F-AAB7-ACB73DC0DBB8}"/>
+                <a16:creationId xmlns:a16="http://schemas.microsoft.com/office/drawing/2014/main" id="{B1B81C7E-B673-4695-A80A-CED30CFC5C51}"/>
               </a:ext>
             </a:extLst>
           </p:cNvPr>
@@ -1981,7 +1981,7 @@
           <p:cNvPr id="4" name="">
             <a:extLst xmlns:a="http://schemas.openxmlformats.org/drawingml/2006/main">
               <a:ext uri="{FF2B5EF4-FFF2-40B4-BE49-F238E27FC236}">
-                <a16:creationId xmlns:a16="http://schemas.microsoft.com/office/drawing/2014/main" id="{02831D35-BC22-4561-A935-049D045E9BEA}"/>
+                <a16:creationId xmlns:a16="http://schemas.microsoft.com/office/drawing/2014/main" id="{2F55C80D-639F-4859-8450-99C77C769870}"/>
               </a:ext>
             </a:extLst>
           </p:cNvPr>
@@ -2038,7 +2038,7 @@
           <p:cNvPr id="5" name="">
             <a:extLst xmlns:a="http://schemas.openxmlformats.org/drawingml/2006/main">
               <a:ext uri="{FF2B5EF4-FFF2-40B4-BE49-F238E27FC236}">
-                <a16:creationId xmlns:a16="http://schemas.microsoft.com/office/drawing/2014/main" id="{365AA8A0-6755-490C-872C-1E776C0ED06D}"/>
+                <a16:creationId xmlns:a16="http://schemas.microsoft.com/office/drawing/2014/main" id="{9F90DC65-FFD7-4DE4-8B8F-88AA8CC02EED}"/>
               </a:ext>
             </a:extLst>
           </p:cNvPr>
@@ -2095,7 +2095,7 @@
           <p:cNvPr id="6" name="">
             <a:extLst xmlns:a="http://schemas.openxmlformats.org/drawingml/2006/main">
               <a:ext uri="{FF2B5EF4-FFF2-40B4-BE49-F238E27FC236}">
-                <a16:creationId xmlns:a16="http://schemas.microsoft.com/office/drawing/2014/main" id="{F3179FA4-B3E4-456F-9217-B278195EF05B}"/>
+                <a16:creationId xmlns:a16="http://schemas.microsoft.com/office/drawing/2014/main" id="{7596CED8-D9FE-4BA0-BDF0-AB8192C81DA8}"/>
               </a:ext>
             </a:extLst>
           </p:cNvPr>
@@ -2152,7 +2152,7 @@
           <p:cNvPr id="7" name="">
             <a:extLst xmlns:a="http://schemas.openxmlformats.org/drawingml/2006/main">
               <a:ext uri="{FF2B5EF4-FFF2-40B4-BE49-F238E27FC236}">
-                <a16:creationId xmlns:a16="http://schemas.microsoft.com/office/drawing/2014/main" id="{3B4512D2-F013-4ED9-BD24-B1945F461943}"/>
+                <a16:creationId xmlns:a16="http://schemas.microsoft.com/office/drawing/2014/main" id="{2A9D09B8-421F-4934-A094-548845039F5F}"/>
               </a:ext>
             </a:extLst>
           </p:cNvPr>
@@ -2209,7 +2209,7 @@
           <p:cNvPr id="8" name="">
             <a:extLst xmlns:a="http://schemas.openxmlformats.org/drawingml/2006/main">
               <a:ext uri="{FF2B5EF4-FFF2-40B4-BE49-F238E27FC236}">
-                <a16:creationId xmlns:a16="http://schemas.microsoft.com/office/drawing/2014/main" id="{7C5A7751-EF5D-4AF3-B379-941EAB142545}"/>
+                <a16:creationId xmlns:a16="http://schemas.microsoft.com/office/drawing/2014/main" id="{0718FE1E-A775-46BD-8905-FE3D7FFDA491}"/>
               </a:ext>
             </a:extLst>
           </p:cNvPr>
@@ -2266,7 +2266,7 @@
           <p:cNvPr id="9" name="">
             <a:extLst xmlns:a="http://schemas.openxmlformats.org/drawingml/2006/main">
               <a:ext uri="{FF2B5EF4-FFF2-40B4-BE49-F238E27FC236}">
-                <a16:creationId xmlns:a16="http://schemas.microsoft.com/office/drawing/2014/main" id="{A7FC0EF5-AB63-4C0A-B722-8C154EF3EBBC}"/>
+                <a16:creationId xmlns:a16="http://schemas.microsoft.com/office/drawing/2014/main" id="{F9DABD12-BC51-4244-9DC0-79D9F379069A}"/>
               </a:ext>
             </a:extLst>
           </p:cNvPr>
@@ -2323,7 +2323,7 @@
           <p:cNvPr id="10" name="">
             <a:extLst xmlns:a="http://schemas.openxmlformats.org/drawingml/2006/main">
               <a:ext uri="{FF2B5EF4-FFF2-40B4-BE49-F238E27FC236}">
-                <a16:creationId xmlns:a16="http://schemas.microsoft.com/office/drawing/2014/main" id="{52A00A86-A246-4464-B444-07E569C78941}"/>
+                <a16:creationId xmlns:a16="http://schemas.microsoft.com/office/drawing/2014/main" id="{0C381C49-1708-41E5-A360-B678C25E02B7}"/>
               </a:ext>
             </a:extLst>
           </p:cNvPr>
@@ -2380,7 +2380,7 @@
           <p:cNvPr id="11" name="">
             <a:extLst xmlns:a="http://schemas.openxmlformats.org/drawingml/2006/main">
               <a:ext uri="{FF2B5EF4-FFF2-40B4-BE49-F238E27FC236}">
-                <a16:creationId xmlns:a16="http://schemas.microsoft.com/office/drawing/2014/main" id="{177D7B14-239C-4246-8223-D9240B878FCA}"/>
+                <a16:creationId xmlns:a16="http://schemas.microsoft.com/office/drawing/2014/main" id="{54298888-12BB-4846-96FF-E2EDE32836D2}"/>
               </a:ext>
             </a:extLst>
           </p:cNvPr>
@@ -2437,7 +2437,7 @@
           <p:cNvPr id="12" name="">
             <a:extLst xmlns:a="http://schemas.openxmlformats.org/drawingml/2006/main">
               <a:ext uri="{FF2B5EF4-FFF2-40B4-BE49-F238E27FC236}">
-                <a16:creationId xmlns:a16="http://schemas.microsoft.com/office/drawing/2014/main" id="{DE117ED8-29A3-4777-B1FF-E42EE447682A}"/>
+                <a16:creationId xmlns:a16="http://schemas.microsoft.com/office/drawing/2014/main" id="{D79BF030-390B-4DDA-BCC1-FEE2426CE9EC}"/>
               </a:ext>
             </a:extLst>
           </p:cNvPr>
@@ -2494,7 +2494,7 @@
           <p:cNvPr id="13" name="">
             <a:extLst xmlns:a="http://schemas.openxmlformats.org/drawingml/2006/main">
               <a:ext uri="{FF2B5EF4-FFF2-40B4-BE49-F238E27FC236}">
-                <a16:creationId xmlns:a16="http://schemas.microsoft.com/office/drawing/2014/main" id="{DF770B7B-B1AF-473F-9262-01A83FAA69A2}"/>
+                <a16:creationId xmlns:a16="http://schemas.microsoft.com/office/drawing/2014/main" id="{90712DF0-88C4-44CC-B9C1-BBA72142B03B}"/>
               </a:ext>
             </a:extLst>
           </p:cNvPr>
@@ -2551,7 +2551,7 @@
           <p:cNvPr id="14" name="">
             <a:extLst xmlns:a="http://schemas.openxmlformats.org/drawingml/2006/main">
               <a:ext uri="{FF2B5EF4-FFF2-40B4-BE49-F238E27FC236}">
-                <a16:creationId xmlns:a16="http://schemas.microsoft.com/office/drawing/2014/main" id="{83319037-502E-436A-AE7C-5DBD4295AA1E}"/>
+                <a16:creationId xmlns:a16="http://schemas.microsoft.com/office/drawing/2014/main" id="{9C5F3527-4077-4BFB-A275-1EE0A4378B6D}"/>
               </a:ext>
             </a:extLst>
           </p:cNvPr>
@@ -2608,7 +2608,7 @@
           <p:cNvPr id="15" name="">
             <a:extLst xmlns:a="http://schemas.openxmlformats.org/drawingml/2006/main">
               <a:ext uri="{FF2B5EF4-FFF2-40B4-BE49-F238E27FC236}">
-                <a16:creationId xmlns:a16="http://schemas.microsoft.com/office/drawing/2014/main" id="{29D9130B-3413-4E94-B6D2-76769CB7C88F}"/>
+                <a16:creationId xmlns:a16="http://schemas.microsoft.com/office/drawing/2014/main" id="{84C0C6BE-7EB1-4733-A6BB-AABAF18EC4B8}"/>
               </a:ext>
             </a:extLst>
           </p:cNvPr>
@@ -2665,7 +2665,7 @@
           <p:cNvPr id="16" name="">
             <a:extLst xmlns:a="http://schemas.openxmlformats.org/drawingml/2006/main">
               <a:ext uri="{FF2B5EF4-FFF2-40B4-BE49-F238E27FC236}">
-                <a16:creationId xmlns:a16="http://schemas.microsoft.com/office/drawing/2014/main" id="{B87C8DAA-036C-42B1-A76C-962B5A28F71D}"/>
+                <a16:creationId xmlns:a16="http://schemas.microsoft.com/office/drawing/2014/main" id="{23289220-0FD1-46E4-A73E-EAEB884FDDA5}"/>
               </a:ext>
             </a:extLst>
           </p:cNvPr>
@@ -2722,7 +2722,7 @@
           <p:cNvPr id="17" name="">
             <a:extLst xmlns:a="http://schemas.openxmlformats.org/drawingml/2006/main">
               <a:ext uri="{FF2B5EF4-FFF2-40B4-BE49-F238E27FC236}">
-                <a16:creationId xmlns:a16="http://schemas.microsoft.com/office/drawing/2014/main" id="{437245E7-DF22-4786-B0D4-D2F0A0A93349}"/>
+                <a16:creationId xmlns:a16="http://schemas.microsoft.com/office/drawing/2014/main" id="{7D888013-61B3-4C50-ADE1-3CF298FEFDA7}"/>
               </a:ext>
             </a:extLst>
           </p:cNvPr>
@@ -2779,7 +2779,7 @@
           <p:cNvPr id="18" name="">
             <a:extLst xmlns:a="http://schemas.openxmlformats.org/drawingml/2006/main">
               <a:ext uri="{FF2B5EF4-FFF2-40B4-BE49-F238E27FC236}">
-                <a16:creationId xmlns:a16="http://schemas.microsoft.com/office/drawing/2014/main" id="{A1C30373-5BB8-4E6E-9CE4-2778A450087D}"/>
+                <a16:creationId xmlns:a16="http://schemas.microsoft.com/office/drawing/2014/main" id="{4AC6027D-DC8E-471F-80F6-6A3777095EA6}"/>
               </a:ext>
             </a:extLst>
           </p:cNvPr>
@@ -2834,7 +2834,7 @@
     </p:spTree>
     <p:extLst>
       <p:ext uri="{BB962C8B-B14F-4D97-AF65-F5344CB8AC3E}">
-        <p14:creationId xmlns:p14="http://schemas.microsoft.com/office/powerpoint/2010/main" val="1314388329"/>
+        <p14:creationId xmlns:p14="http://schemas.microsoft.com/office/powerpoint/2010/main" val="871903996"/>
       </p:ext>
     </p:extLst>
   </p:cSld>
@@ -2865,7 +2865,7 @@
           <p:cNvPr id="13" name="">
             <a:extLst xmlns:a="http://schemas.openxmlformats.org/drawingml/2006/main">
               <a:ext uri="{FF2B5EF4-FFF2-40B4-BE49-F238E27FC236}">
-                <a16:creationId xmlns:a16="http://schemas.microsoft.com/office/drawing/2014/main" id="{0B9F2245-CAA2-4F76-A1CC-150A5C83D5F7}"/>
+                <a16:creationId xmlns:a16="http://schemas.microsoft.com/office/drawing/2014/main" id="{06728005-1F95-4907-9688-DC5471EFDAC3}"/>
               </a:ext>
             </a:extLst>
           </p:cNvPr>
@@ -2922,7 +2922,7 @@
           <p:cNvPr id="2" name="">
             <a:extLst xmlns:a="http://schemas.openxmlformats.org/drawingml/2006/main">
               <a:ext uri="{FF2B5EF4-FFF2-40B4-BE49-F238E27FC236}">
-                <a16:creationId xmlns:a16="http://schemas.microsoft.com/office/drawing/2014/main" id="{C4C25EA7-9138-4C49-8669-F2C1EE2C60D3}"/>
+                <a16:creationId xmlns:a16="http://schemas.microsoft.com/office/drawing/2014/main" id="{BAAFAF8E-B2C8-4E29-A06A-03A070B44877}"/>
               </a:ext>
             </a:extLst>
           </p:cNvPr>
@@ -2979,7 +2979,7 @@
           <p:cNvPr id="3" name="">
             <a:extLst xmlns:a="http://schemas.openxmlformats.org/drawingml/2006/main">
               <a:ext uri="{FF2B5EF4-FFF2-40B4-BE49-F238E27FC236}">
-                <a16:creationId xmlns:a16="http://schemas.microsoft.com/office/drawing/2014/main" id="{DF8264B0-7A38-405B-BDF8-F8A33401F708}"/>
+                <a16:creationId xmlns:a16="http://schemas.microsoft.com/office/drawing/2014/main" id="{F606D034-97BA-4672-938C-D29DC881F4EF}"/>
               </a:ext>
             </a:extLst>
           </p:cNvPr>
@@ -3036,7 +3036,7 @@
           <p:cNvPr id="4" name="">
             <a:extLst xmlns:a="http://schemas.openxmlformats.org/drawingml/2006/main">
               <a:ext uri="{FF2B5EF4-FFF2-40B4-BE49-F238E27FC236}">
-                <a16:creationId xmlns:a16="http://schemas.microsoft.com/office/drawing/2014/main" id="{E6D372F5-CDAE-4B65-AF03-7B1EBA48A53D}"/>
+                <a16:creationId xmlns:a16="http://schemas.microsoft.com/office/drawing/2014/main" id="{93FC0BB7-BA77-47E7-8980-0057F27A14B1}"/>
               </a:ext>
             </a:extLst>
           </p:cNvPr>
@@ -3083,7 +3083,7 @@
                 <a:ea typeface="Arial"/>
                 <a:cs typeface="Arial"/>
               </a:rPr>
-              <a:t>Planned acceptance run using real OpenAI services</a:t>
+              <a:t>Acceptance scenario · latest rehearsal incomplete</a:t>
             </a:r>
           </a:p>
         </p:txBody>
@@ -3093,7 +3093,7 @@
           <p:cNvPr id="5" name="">
             <a:extLst xmlns:a="http://schemas.openxmlformats.org/drawingml/2006/main">
               <a:ext uri="{FF2B5EF4-FFF2-40B4-BE49-F238E27FC236}">
-                <a16:creationId xmlns:a16="http://schemas.microsoft.com/office/drawing/2014/main" id="{5AC5DC41-49CE-45DF-8494-2FC6BC60847B}"/>
+                <a16:creationId xmlns:a16="http://schemas.microsoft.com/office/drawing/2014/main" id="{C7AB5733-4B40-497C-8893-2A1076AC056B}"/>
               </a:ext>
             </a:extLst>
           </p:cNvPr>
@@ -3150,7 +3150,7 @@
           <p:cNvPr id="6" name="">
             <a:extLst xmlns:a="http://schemas.openxmlformats.org/drawingml/2006/main">
               <a:ext uri="{FF2B5EF4-FFF2-40B4-BE49-F238E27FC236}">
-                <a16:creationId xmlns:a16="http://schemas.microsoft.com/office/drawing/2014/main" id="{7CE5AB18-CB75-4D06-81AE-B8704FC9C69B}"/>
+                <a16:creationId xmlns:a16="http://schemas.microsoft.com/office/drawing/2014/main" id="{E89161F1-BF98-41F9-A41B-B07E6D3FA369}"/>
               </a:ext>
             </a:extLst>
           </p:cNvPr>
@@ -3207,7 +3207,7 @@
           <p:cNvPr id="7" name="">
             <a:extLst xmlns:a="http://schemas.openxmlformats.org/drawingml/2006/main">
               <a:ext uri="{FF2B5EF4-FFF2-40B4-BE49-F238E27FC236}">
-                <a16:creationId xmlns:a16="http://schemas.microsoft.com/office/drawing/2014/main" id="{99EE6AF3-7D04-4F3D-9707-2E33BCC6EF09}"/>
+                <a16:creationId xmlns:a16="http://schemas.microsoft.com/office/drawing/2014/main" id="{FE968D87-F04C-43E2-912E-3E519B7055C7}"/>
               </a:ext>
             </a:extLst>
           </p:cNvPr>
@@ -3310,7 +3310,7 @@
           <p:cNvPr id="8" name="">
             <a:extLst xmlns:a="http://schemas.openxmlformats.org/drawingml/2006/main">
               <a:ext uri="{FF2B5EF4-FFF2-40B4-BE49-F238E27FC236}">
-                <a16:creationId xmlns:a16="http://schemas.microsoft.com/office/drawing/2014/main" id="{E55AC26F-076D-4BC1-A5E3-D9C399BB2489}"/>
+                <a16:creationId xmlns:a16="http://schemas.microsoft.com/office/drawing/2014/main" id="{FF478F56-E70A-4CD6-B219-EE30D8039D14}"/>
               </a:ext>
             </a:extLst>
           </p:cNvPr>
@@ -3367,7 +3367,7 @@
           <p:cNvPr id="9" name="">
             <a:extLst xmlns:a="http://schemas.openxmlformats.org/drawingml/2006/main">
               <a:ext uri="{FF2B5EF4-FFF2-40B4-BE49-F238E27FC236}">
-                <a16:creationId xmlns:a16="http://schemas.microsoft.com/office/drawing/2014/main" id="{6456CB33-75E1-4EC8-A9BE-C047C40F5D9F}"/>
+                <a16:creationId xmlns:a16="http://schemas.microsoft.com/office/drawing/2014/main" id="{D40353E8-76F9-46E8-9A4C-41F3B5C955B5}"/>
               </a:ext>
             </a:extLst>
           </p:cNvPr>
@@ -3447,7 +3447,7 @@
           <p:cNvPr id="10" name="">
             <a:extLst xmlns:a="http://schemas.openxmlformats.org/drawingml/2006/main">
               <a:ext uri="{FF2B5EF4-FFF2-40B4-BE49-F238E27FC236}">
-                <a16:creationId xmlns:a16="http://schemas.microsoft.com/office/drawing/2014/main" id="{31CD1E9F-6441-461B-B761-4FBC418FA745}"/>
+                <a16:creationId xmlns:a16="http://schemas.microsoft.com/office/drawing/2014/main" id="{6CB250AB-1F60-4034-A572-9AD644AC2213}"/>
               </a:ext>
             </a:extLst>
           </p:cNvPr>
@@ -3550,7 +3550,7 @@
           <p:cNvPr id="11" name="">
             <a:extLst xmlns:a="http://schemas.openxmlformats.org/drawingml/2006/main">
               <a:ext uri="{FF2B5EF4-FFF2-40B4-BE49-F238E27FC236}">
-                <a16:creationId xmlns:a16="http://schemas.microsoft.com/office/drawing/2014/main" id="{36BB8954-DDCC-43EA-B6FF-0240833094BB}"/>
+                <a16:creationId xmlns:a16="http://schemas.microsoft.com/office/drawing/2014/main" id="{A3465E71-C355-4637-8F5A-5AC9FB7493F5}"/>
               </a:ext>
             </a:extLst>
           </p:cNvPr>
@@ -3630,7 +3630,7 @@
           <p:cNvPr id="12" name="">
             <a:extLst xmlns:a="http://schemas.openxmlformats.org/drawingml/2006/main">
               <a:ext uri="{FF2B5EF4-FFF2-40B4-BE49-F238E27FC236}">
-                <a16:creationId xmlns:a16="http://schemas.microsoft.com/office/drawing/2014/main" id="{CDB7577E-FA9A-4516-88BD-F2AA55FC6EB2}"/>
+                <a16:creationId xmlns:a16="http://schemas.microsoft.com/office/drawing/2014/main" id="{7BA9D32D-4DDB-4EFF-93D8-24020444ECFD}"/>
               </a:ext>
             </a:extLst>
           </p:cNvPr>
@@ -3685,7 +3685,7 @@
     </p:spTree>
     <p:extLst>
       <p:ext uri="{BB962C8B-B14F-4D97-AF65-F5344CB8AC3E}">
-        <p14:creationId xmlns:p14="http://schemas.microsoft.com/office/powerpoint/2010/main" val="662049191"/>
+        <p14:creationId xmlns:p14="http://schemas.microsoft.com/office/powerpoint/2010/main" val="105122681"/>
       </p:ext>
     </p:extLst>
   </p:cSld>
@@ -3713,10 +3713,10 @@
       </p:grpSpPr>
       <p:sp>
         <p:nvSpPr>
-          <p:cNvPr id="12" name="">
-            <a:extLst xmlns:a="http://schemas.openxmlformats.org/drawingml/2006/main">
-              <a:ext uri="{FF2B5EF4-FFF2-40B4-BE49-F238E27FC236}">
-                <a16:creationId xmlns:a16="http://schemas.microsoft.com/office/drawing/2014/main" id="{1B3469B0-D1DB-4A54-BFBC-F84E118D5341}"/>
+          <p:cNvPr id="11" name="">
+            <a:extLst xmlns:a="http://schemas.openxmlformats.org/drawingml/2006/main">
+              <a:ext uri="{FF2B5EF4-FFF2-40B4-BE49-F238E27FC236}">
+                <a16:creationId xmlns:a16="http://schemas.microsoft.com/office/drawing/2014/main" id="{83D6E00D-31BF-479D-B56F-81AB9A9CA8A0}"/>
               </a:ext>
             </a:extLst>
           </p:cNvPr>
@@ -3763,7 +3763,7 @@
                 <a:ea typeface="Arial"/>
                 <a:cs typeface="Arial"/>
               </a:rPr>
-              <a:t>What is verified</a:t>
+              <a:t>Codex work and verification</a:t>
             </a:r>
           </a:p>
         </p:txBody>
@@ -3773,7 +3773,7 @@
           <p:cNvPr id="2" name="">
             <a:extLst xmlns:a="http://schemas.openxmlformats.org/drawingml/2006/main">
               <a:ext uri="{FF2B5EF4-FFF2-40B4-BE49-F238E27FC236}">
-                <a16:creationId xmlns:a16="http://schemas.microsoft.com/office/drawing/2014/main" id="{2C3C8AC7-9168-48CD-BC85-505C622ADC58}"/>
+                <a16:creationId xmlns:a16="http://schemas.microsoft.com/office/drawing/2014/main" id="{1E899E29-4481-44A5-86D2-12B5647BFB5C}"/>
               </a:ext>
             </a:extLst>
           </p:cNvPr>
@@ -3830,7 +3830,7 @@
           <p:cNvPr id="3" name="">
             <a:extLst xmlns:a="http://schemas.openxmlformats.org/drawingml/2006/main">
               <a:ext uri="{FF2B5EF4-FFF2-40B4-BE49-F238E27FC236}">
-                <a16:creationId xmlns:a16="http://schemas.microsoft.com/office/drawing/2014/main" id="{B4F348B6-EF36-46BB-A30A-FA572C284FEB}"/>
+                <a16:creationId xmlns:a16="http://schemas.microsoft.com/office/drawing/2014/main" id="{D164E1C7-3165-4E67-A71E-5C3E8DE1E4BE}"/>
               </a:ext>
             </a:extLst>
           </p:cNvPr>
@@ -3887,18 +3887,18 @@
           <p:cNvPr id="4" name="">
             <a:extLst xmlns:a="http://schemas.openxmlformats.org/drawingml/2006/main">
               <a:ext uri="{FF2B5EF4-FFF2-40B4-BE49-F238E27FC236}">
-                <a16:creationId xmlns:a16="http://schemas.microsoft.com/office/drawing/2014/main" id="{38D88F2E-9C1B-486B-98C5-D872D2848F1B}"/>
-              </a:ext>
-            </a:extLst>
-          </p:cNvPr>
-          <p:cNvSpPr>
-            <a:spLocks xmlns:a="http://schemas.openxmlformats.org/drawingml/2006/main" noGrp="1"/>
-          </p:cNvSpPr>
-          <p:nvPr/>
-        </p:nvSpPr>
-        <p:spPr>
-          <a:xfrm xmlns:a="http://schemas.openxmlformats.org/drawingml/2006/main">
-            <a:off x="704850" y="1552575"/>
+                <a16:creationId xmlns:a16="http://schemas.microsoft.com/office/drawing/2014/main" id="{A6215D9B-796F-4CF0-BD27-A7573280AFEC}"/>
+              </a:ext>
+            </a:extLst>
+          </p:cNvPr>
+          <p:cNvSpPr>
+            <a:spLocks xmlns:a="http://schemas.openxmlformats.org/drawingml/2006/main" noGrp="1"/>
+          </p:cNvSpPr>
+          <p:nvPr/>
+        </p:nvSpPr>
+        <p:spPr>
+          <a:xfrm xmlns:a="http://schemas.openxmlformats.org/drawingml/2006/main">
+            <a:off x="704850" y="1495425"/>
             <a:ext cx="10668000" cy="428625"/>
           </a:xfrm>
           <a:prstGeom xmlns:a="http://schemas.openxmlformats.org/drawingml/2006/main" prst="rect">
@@ -3916,6 +3916,200 @@
           <a:lstStyle xmlns:a="http://schemas.openxmlformats.org/drawingml/2006/main"/>
           <a:p xmlns:a="http://schemas.openxmlformats.org/drawingml/2006/main">
             <a:pPr>
+              <a:defRPr sz="2250" b="1">
+                <a:solidFill>
+                  <a:srgbClr val="1B5147"/>
+                </a:solidFill>
+                <a:latin typeface="Arial"/>
+                <a:ea typeface="Arial"/>
+                <a:cs typeface="Arial"/>
+              </a:defRPr>
+            </a:pPr>
+            <a:r>
+              <a:rPr sz="2250" b="1">
+                <a:solidFill>
+                  <a:srgbClr val="1B5147"/>
+                </a:solidFill>
+                <a:latin typeface="Arial"/>
+                <a:ea typeface="Arial"/>
+                <a:cs typeface="Arial"/>
+              </a:rPr>
+              <a:t>Codex built the chat, call state, and test harnesses</a:t>
+            </a:r>
+          </a:p>
+        </p:txBody>
+      </p:sp>
+      <p:sp>
+        <p:nvSpPr>
+          <p:cNvPr id="5" name="">
+            <a:extLst xmlns:a="http://schemas.openxmlformats.org/drawingml/2006/main">
+              <a:ext uri="{FF2B5EF4-FFF2-40B4-BE49-F238E27FC236}">
+                <a16:creationId xmlns:a16="http://schemas.microsoft.com/office/drawing/2014/main" id="{0BA446E1-B1A0-4A00-A88B-975B23EA2112}"/>
+              </a:ext>
+            </a:extLst>
+          </p:cNvPr>
+          <p:cNvSpPr>
+            <a:spLocks xmlns:a="http://schemas.openxmlformats.org/drawingml/2006/main" noGrp="1"/>
+          </p:cNvSpPr>
+          <p:nvPr/>
+        </p:nvSpPr>
+        <p:spPr>
+          <a:xfrm xmlns:a="http://schemas.openxmlformats.org/drawingml/2006/main">
+            <a:off x="704850" y="1952625"/>
+            <a:ext cx="10668000" cy="752475"/>
+          </a:xfrm>
+          <a:prstGeom xmlns:a="http://schemas.openxmlformats.org/drawingml/2006/main" prst="rect">
+            <a:avLst/>
+          </a:prstGeom>
+          <a:noFill xmlns:a="http://schemas.openxmlformats.org/drawingml/2006/main"/>
+          <a:ln xmlns:a="http://schemas.openxmlformats.org/drawingml/2006/main" w="0">
+            <a:noFill/>
+          </a:ln>
+        </p:spPr>
+        <p:txBody>
+          <a:bodyPr xmlns:a="http://schemas.openxmlformats.org/drawingml/2006/main" anchor="t">
+            <a:noAutofit/>
+          </a:bodyPr>
+          <a:lstStyle xmlns:a="http://schemas.openxmlformats.org/drawingml/2006/main"/>
+          <a:p xmlns:a="http://schemas.openxmlformats.org/drawingml/2006/main">
+            <a:pPr>
+              <a:defRPr sz="2025" b="0">
+                <a:solidFill>
+                  <a:srgbClr val="1B5147"/>
+                </a:solidFill>
+                <a:latin typeface="Arial"/>
+                <a:ea typeface="Arial"/>
+                <a:cs typeface="Arial"/>
+              </a:defRPr>
+            </a:pPr>
+            <a:r>
+              <a:rPr sz="2025" b="0">
+                <a:solidFill>
+                  <a:srgbClr val="1B5147"/>
+                </a:solidFill>
+                <a:latin typeface="Arial"/>
+                <a:ea typeface="Arial"/>
+                <a:cs typeface="Arial"/>
+              </a:rPr>
+              <a:t>57 code + 17 HTTP checks passed. Mocked browser checks:</a:t>
+            </a:r>
+          </a:p>
+          <a:p xmlns:a="http://schemas.openxmlformats.org/drawingml/2006/main">
+            <a:pPr>
+              <a:defRPr sz="2025" b="0">
+                <a:solidFill>
+                  <a:srgbClr val="1B5147"/>
+                </a:solidFill>
+                <a:latin typeface="Arial"/>
+                <a:ea typeface="Arial"/>
+                <a:cs typeface="Arial"/>
+              </a:defRPr>
+            </a:pPr>
+            <a:r>
+              <a:rPr sz="2025" b="0">
+                <a:solidFill>
+                  <a:srgbClr val="1B5147"/>
+                </a:solidFill>
+                <a:latin typeface="Arial"/>
+                <a:ea typeface="Arial"/>
+                <a:cs typeface="Arial"/>
+              </a:rPr>
+              <a:t>20 customer + 11 business checks passed.</a:t>
+            </a:r>
+          </a:p>
+        </p:txBody>
+      </p:sp>
+      <p:sp>
+        <p:nvSpPr>
+          <p:cNvPr id="6" name="">
+            <a:extLst xmlns:a="http://schemas.openxmlformats.org/drawingml/2006/main">
+              <a:ext uri="{FF2B5EF4-FFF2-40B4-BE49-F238E27FC236}">
+                <a16:creationId xmlns:a16="http://schemas.microsoft.com/office/drawing/2014/main" id="{705983EC-155A-403C-8306-0CDD0D619295}"/>
+              </a:ext>
+            </a:extLst>
+          </p:cNvPr>
+          <p:cNvSpPr>
+            <a:spLocks xmlns:a="http://schemas.openxmlformats.org/drawingml/2006/main" noGrp="1"/>
+          </p:cNvSpPr>
+          <p:nvPr/>
+        </p:nvSpPr>
+        <p:spPr>
+          <a:xfrm xmlns:a="http://schemas.openxmlformats.org/drawingml/2006/main">
+            <a:off x="704850" y="2724150"/>
+            <a:ext cx="10668000" cy="314325"/>
+          </a:xfrm>
+          <a:prstGeom xmlns:a="http://schemas.openxmlformats.org/drawingml/2006/main" prst="rect">
+            <a:avLst/>
+          </a:prstGeom>
+          <a:noFill xmlns:a="http://schemas.openxmlformats.org/drawingml/2006/main"/>
+          <a:ln xmlns:a="http://schemas.openxmlformats.org/drawingml/2006/main" w="0">
+            <a:noFill/>
+          </a:ln>
+        </p:spPr>
+        <p:txBody>
+          <a:bodyPr xmlns:a="http://schemas.openxmlformats.org/drawingml/2006/main" anchor="t">
+            <a:noAutofit/>
+          </a:bodyPr>
+          <a:lstStyle xmlns:a="http://schemas.openxmlformats.org/drawingml/2006/main"/>
+          <a:p xmlns:a="http://schemas.openxmlformats.org/drawingml/2006/main">
+            <a:pPr>
+              <a:defRPr sz="1575" b="0">
+                <a:solidFill>
+                  <a:srgbClr val="64756D"/>
+                </a:solidFill>
+                <a:latin typeface="Arial"/>
+                <a:ea typeface="Arial"/>
+                <a:cs typeface="Arial"/>
+              </a:defRPr>
+            </a:pPr>
+            <a:r>
+              <a:rPr sz="1575" b="0">
+                <a:solidFill>
+                  <a:srgbClr val="64756D"/>
+                </a:solidFill>
+                <a:latin typeface="Arial"/>
+                <a:ea typeface="Arial"/>
+                <a:cs typeface="Arial"/>
+              </a:rPr>
+              <a:t>These checks do not establish real speech quality or user value.</a:t>
+            </a:r>
+          </a:p>
+        </p:txBody>
+      </p:sp>
+      <p:sp>
+        <p:nvSpPr>
+          <p:cNvPr id="7" name="">
+            <a:extLst xmlns:a="http://schemas.openxmlformats.org/drawingml/2006/main">
+              <a:ext uri="{FF2B5EF4-FFF2-40B4-BE49-F238E27FC236}">
+                <a16:creationId xmlns:a16="http://schemas.microsoft.com/office/drawing/2014/main" id="{E3F62FB0-1F62-4236-A53E-D232CB80A57F}"/>
+              </a:ext>
+            </a:extLst>
+          </p:cNvPr>
+          <p:cNvSpPr>
+            <a:spLocks xmlns:a="http://schemas.openxmlformats.org/drawingml/2006/main" noGrp="1"/>
+          </p:cNvSpPr>
+          <p:nvPr/>
+        </p:nvSpPr>
+        <p:spPr>
+          <a:xfrm xmlns:a="http://schemas.openxmlformats.org/drawingml/2006/main">
+            <a:off x="704850" y="3324225"/>
+            <a:ext cx="10668000" cy="428625"/>
+          </a:xfrm>
+          <a:prstGeom xmlns:a="http://schemas.openxmlformats.org/drawingml/2006/main" prst="rect">
+            <a:avLst/>
+          </a:prstGeom>
+          <a:noFill xmlns:a="http://schemas.openxmlformats.org/drawingml/2006/main"/>
+          <a:ln xmlns:a="http://schemas.openxmlformats.org/drawingml/2006/main" w="0">
+            <a:noFill/>
+          </a:ln>
+        </p:spPr>
+        <p:txBody>
+          <a:bodyPr xmlns:a="http://schemas.openxmlformats.org/drawingml/2006/main" anchor="t">
+            <a:noAutofit/>
+          </a:bodyPr>
+          <a:lstStyle xmlns:a="http://schemas.openxmlformats.org/drawingml/2006/main"/>
+          <a:p xmlns:a="http://schemas.openxmlformats.org/drawingml/2006/main">
+            <a:pPr>
               <a:defRPr sz="2325" b="1">
                 <a:solidFill>
                   <a:srgbClr val="1B5147"/>
@@ -3934,85 +4128,108 @@
                 <a:ea typeface="Arial"/>
                 <a:cs typeface="Arial"/>
               </a:rPr>
-              <a:t>Customer interface and Codex checks</a:t>
-            </a:r>
-          </a:p>
-        </p:txBody>
-      </p:sp>
-      <p:sp>
-        <p:nvSpPr>
-          <p:cNvPr id="5" name="">
-            <a:extLst xmlns:a="http://schemas.openxmlformats.org/drawingml/2006/main">
-              <a:ext uri="{FF2B5EF4-FFF2-40B4-BE49-F238E27FC236}">
-                <a16:creationId xmlns:a16="http://schemas.microsoft.com/office/drawing/2014/main" id="{215DFD8D-0070-40CC-94B4-916688B37800}"/>
-              </a:ext>
-            </a:extLst>
-          </p:cNvPr>
-          <p:cNvSpPr>
-            <a:spLocks xmlns:a="http://schemas.openxmlformats.org/drawingml/2006/main" noGrp="1"/>
-          </p:cNvSpPr>
-          <p:nvPr/>
-        </p:nvSpPr>
-        <p:spPr>
-          <a:xfrm xmlns:a="http://schemas.openxmlformats.org/drawingml/2006/main">
-            <a:off x="704850" y="2009775"/>
-            <a:ext cx="10668000" cy="514350"/>
-          </a:xfrm>
-          <a:prstGeom xmlns:a="http://schemas.openxmlformats.org/drawingml/2006/main" prst="rect">
-            <a:avLst/>
-          </a:prstGeom>
-          <a:noFill xmlns:a="http://schemas.openxmlformats.org/drawingml/2006/main"/>
-          <a:ln xmlns:a="http://schemas.openxmlformats.org/drawingml/2006/main" w="0">
-            <a:noFill/>
-          </a:ln>
-        </p:spPr>
-        <p:txBody>
-          <a:bodyPr xmlns:a="http://schemas.openxmlformats.org/drawingml/2006/main" anchor="t">
-            <a:noAutofit/>
-          </a:bodyPr>
-          <a:lstStyle xmlns:a="http://schemas.openxmlformats.org/drawingml/2006/main"/>
-          <a:p xmlns:a="http://schemas.openxmlformats.org/drawingml/2006/main">
-            <a:pPr>
-              <a:defRPr sz="2100" b="0">
-                <a:solidFill>
-                  <a:srgbClr val="1B5147"/>
-                </a:solidFill>
-                <a:latin typeface="Arial"/>
-                <a:ea typeface="Arial"/>
-                <a:cs typeface="Arial"/>
-              </a:defRPr>
-            </a:pPr>
-            <a:r>
-              <a:rPr sz="2100" b="0">
-                <a:solidFill>
-                  <a:srgbClr val="1B5147"/>
-                </a:solidFill>
-                <a:latin typeface="Arial"/>
-                <a:ea typeface="Arial"/>
-                <a:cs typeface="Arial"/>
-              </a:rPr>
-              <a:t>20 synthetic browser checks passed across English, Russian, and Chinese.</a:t>
-            </a:r>
-          </a:p>
-        </p:txBody>
-      </p:sp>
-      <p:sp>
-        <p:nvSpPr>
-          <p:cNvPr id="6" name="">
-            <a:extLst xmlns:a="http://schemas.openxmlformats.org/drawingml/2006/main">
-              <a:ext uri="{FF2B5EF4-FFF2-40B4-BE49-F238E27FC236}">
-                <a16:creationId xmlns:a16="http://schemas.microsoft.com/office/drawing/2014/main" id="{2BB540F9-BB90-420D-8B2A-29F5EC80A688}"/>
-              </a:ext>
-            </a:extLst>
-          </p:cNvPr>
-          <p:cNvSpPr>
-            <a:spLocks xmlns:a="http://schemas.openxmlformats.org/drawingml/2006/main" noGrp="1"/>
-          </p:cNvSpPr>
-          <p:nvPr/>
-        </p:nvSpPr>
-        <p:spPr>
-          <a:xfrm xmlns:a="http://schemas.openxmlformats.org/drawingml/2006/main">
-            <a:off x="704850" y="2533650"/>
+              <a:t>Actual Korean speech: Partial</a:t>
+            </a:r>
+          </a:p>
+        </p:txBody>
+      </p:sp>
+      <p:sp>
+        <p:nvSpPr>
+          <p:cNvPr id="8" name="">
+            <a:extLst xmlns:a="http://schemas.openxmlformats.org/drawingml/2006/main">
+              <a:ext uri="{FF2B5EF4-FFF2-40B4-BE49-F238E27FC236}">
+                <a16:creationId xmlns:a16="http://schemas.microsoft.com/office/drawing/2014/main" id="{D1A2F8DF-D7E9-496A-B06C-2D47491E58E6}"/>
+              </a:ext>
+            </a:extLst>
+          </p:cNvPr>
+          <p:cNvSpPr>
+            <a:spLocks xmlns:a="http://schemas.openxmlformats.org/drawingml/2006/main" noGrp="1"/>
+          </p:cNvSpPr>
+          <p:nvPr/>
+        </p:nvSpPr>
+        <p:spPr>
+          <a:xfrm xmlns:a="http://schemas.openxmlformats.org/drawingml/2006/main">
+            <a:off x="704850" y="3800475"/>
+            <a:ext cx="10668000" cy="762000"/>
+          </a:xfrm>
+          <a:prstGeom xmlns:a="http://schemas.openxmlformats.org/drawingml/2006/main" prst="rect">
+            <a:avLst/>
+          </a:prstGeom>
+          <a:noFill xmlns:a="http://schemas.openxmlformats.org/drawingml/2006/main"/>
+          <a:ln xmlns:a="http://schemas.openxmlformats.org/drawingml/2006/main" w="0">
+            <a:noFill/>
+          </a:ln>
+        </p:spPr>
+        <p:txBody>
+          <a:bodyPr xmlns:a="http://schemas.openxmlformats.org/drawingml/2006/main" anchor="t">
+            <a:noAutofit/>
+          </a:bodyPr>
+          <a:lstStyle xmlns:a="http://schemas.openxmlformats.org/drawingml/2006/main"/>
+          <a:p xmlns:a="http://schemas.openxmlformats.org/drawingml/2006/main">
+            <a:pPr>
+              <a:defRPr sz="2025" b="0">
+                <a:solidFill>
+                  <a:srgbClr val="1B5147"/>
+                </a:solidFill>
+                <a:latin typeface="Arial"/>
+                <a:ea typeface="Arial"/>
+                <a:cs typeface="Arial"/>
+              </a:defRPr>
+            </a:pPr>
+            <a:r>
+              <a:rPr sz="2025" b="0">
+                <a:solidFill>
+                  <a:srgbClr val="1B5147"/>
+                </a:solidFill>
+                <a:latin typeface="Arial"/>
+                <a:ea typeface="Arial"/>
+                <a:cs typeface="Arial"/>
+              </a:rPr>
+              <a:t>Four spoken answers and a Korean readback were captured.</a:t>
+            </a:r>
+          </a:p>
+          <a:p xmlns:a="http://schemas.openxmlformats.org/drawingml/2006/main">
+            <a:pPr>
+              <a:defRPr sz="2025" b="0">
+                <a:solidFill>
+                  <a:srgbClr val="1B5147"/>
+                </a:solidFill>
+                <a:latin typeface="Arial"/>
+                <a:ea typeface="Arial"/>
+                <a:cs typeface="Arial"/>
+              </a:defRPr>
+            </a:pPr>
+            <a:r>
+              <a:rPr sz="2025" b="0">
+                <a:solidFill>
+                  <a:srgbClr val="1B5147"/>
+                </a:solidFill>
+                <a:latin typeface="Arial"/>
+                <a:ea typeface="Arial"/>
+                <a:cs typeface="Arial"/>
+              </a:rPr>
+              <a:t>Confirmation reset the answers; the teammate ended the run.</a:t>
+            </a:r>
+          </a:p>
+        </p:txBody>
+      </p:sp>
+      <p:sp>
+        <p:nvSpPr>
+          <p:cNvPr id="9" name="">
+            <a:extLst xmlns:a="http://schemas.openxmlformats.org/drawingml/2006/main">
+              <a:ext uri="{FF2B5EF4-FFF2-40B4-BE49-F238E27FC236}">
+                <a16:creationId xmlns:a16="http://schemas.microsoft.com/office/drawing/2014/main" id="{874F917E-662B-48B9-A292-E787698B10F1}"/>
+              </a:ext>
+            </a:extLst>
+          </p:cNvPr>
+          <p:cNvSpPr>
+            <a:spLocks xmlns:a="http://schemas.openxmlformats.org/drawingml/2006/main" noGrp="1"/>
+          </p:cNvSpPr>
+          <p:nvPr/>
+        </p:nvSpPr>
+        <p:spPr>
+          <a:xfrm xmlns:a="http://schemas.openxmlformats.org/drawingml/2006/main">
+            <a:off x="704850" y="5010150"/>
             <a:ext cx="10668000" cy="409575"/>
           </a:xfrm>
           <a:prstGeom xmlns:a="http://schemas.openxmlformats.org/drawingml/2006/main" prst="rect">
@@ -4030,66 +4247,9 @@
           <a:lstStyle xmlns:a="http://schemas.openxmlformats.org/drawingml/2006/main"/>
           <a:p xmlns:a="http://schemas.openxmlformats.org/drawingml/2006/main">
             <a:pPr>
-              <a:defRPr sz="1725" b="0">
-                <a:solidFill>
-                  <a:srgbClr val="64756D"/>
-                </a:solidFill>
-                <a:latin typeface="Arial"/>
-                <a:ea typeface="Arial"/>
-                <a:cs typeface="Arial"/>
-              </a:defRPr>
-            </a:pPr>
-            <a:r>
-              <a:rPr sz="1725" b="0">
-                <a:solidFill>
-                  <a:srgbClr val="64756D"/>
-                </a:solidFill>
-                <a:latin typeface="Arial"/>
-                <a:ea typeface="Arial"/>
-                <a:cs typeface="Arial"/>
-              </a:rPr>
-              <a:t>Checks use mocked API responses. They do not verify real AI or speech.</a:t>
-            </a:r>
-          </a:p>
-        </p:txBody>
-      </p:sp>
-      <p:sp>
-        <p:nvSpPr>
-          <p:cNvPr id="7" name="">
-            <a:extLst xmlns:a="http://schemas.openxmlformats.org/drawingml/2006/main">
-              <a:ext uri="{FF2B5EF4-FFF2-40B4-BE49-F238E27FC236}">
-                <a16:creationId xmlns:a16="http://schemas.microsoft.com/office/drawing/2014/main" id="{11F38914-7CE3-406E-AA4A-A531F8CD8DD4}"/>
-              </a:ext>
-            </a:extLst>
-          </p:cNvPr>
-          <p:cNvSpPr>
-            <a:spLocks xmlns:a="http://schemas.openxmlformats.org/drawingml/2006/main" noGrp="1"/>
-          </p:cNvSpPr>
-          <p:nvPr/>
-        </p:nvSpPr>
-        <p:spPr>
-          <a:xfrm xmlns:a="http://schemas.openxmlformats.org/drawingml/2006/main">
-            <a:off x="704850" y="3190875"/>
-            <a:ext cx="10668000" cy="428625"/>
-          </a:xfrm>
-          <a:prstGeom xmlns:a="http://schemas.openxmlformats.org/drawingml/2006/main" prst="rect">
-            <a:avLst/>
-          </a:prstGeom>
-          <a:noFill xmlns:a="http://schemas.openxmlformats.org/drawingml/2006/main"/>
-          <a:ln xmlns:a="http://schemas.openxmlformats.org/drawingml/2006/main" w="0">
-            <a:noFill/>
-          </a:ln>
-        </p:spPr>
-        <p:txBody>
-          <a:bodyPr xmlns:a="http://schemas.openxmlformats.org/drawingml/2006/main" anchor="t">
-            <a:noAutofit/>
-          </a:bodyPr>
-          <a:lstStyle xmlns:a="http://schemas.openxmlformats.org/drawingml/2006/main"/>
-          <a:p xmlns:a="http://schemas.openxmlformats.org/drawingml/2006/main">
-            <a:pPr>
               <a:defRPr sz="2325" b="1">
                 <a:solidFill>
-                  <a:srgbClr val="1B5147"/>
+                  <a:srgbClr val="986224"/>
                 </a:solidFill>
                 <a:latin typeface="Arial"/>
                 <a:ea typeface="Arial"/>
@@ -4099,264 +4259,93 @@
             <a:r>
               <a:rPr sz="2325" b="1">
                 <a:solidFill>
-                  <a:srgbClr val="1B5147"/>
-                </a:solidFill>
-                <a:latin typeface="Arial"/>
-                <a:ea typeface="Arial"/>
-                <a:cs typeface="Arial"/>
-              </a:rPr>
-              <a:t>Live OpenAI conversation</a:t>
-            </a:r>
-          </a:p>
-        </p:txBody>
-      </p:sp>
-      <p:sp>
-        <p:nvSpPr>
-          <p:cNvPr id="8" name="">
-            <a:extLst xmlns:a="http://schemas.openxmlformats.org/drawingml/2006/main">
-              <a:ext uri="{FF2B5EF4-FFF2-40B4-BE49-F238E27FC236}">
-                <a16:creationId xmlns:a16="http://schemas.microsoft.com/office/drawing/2014/main" id="{5E6EC730-A647-4043-8F2B-7187617C0235}"/>
-              </a:ext>
-            </a:extLst>
-          </p:cNvPr>
-          <p:cNvSpPr>
-            <a:spLocks xmlns:a="http://schemas.openxmlformats.org/drawingml/2006/main" noGrp="1"/>
-          </p:cNvSpPr>
-          <p:nvPr/>
-        </p:nvSpPr>
-        <p:spPr>
-          <a:xfrm xmlns:a="http://schemas.openxmlformats.org/drawingml/2006/main">
-            <a:off x="704850" y="3676650"/>
-            <a:ext cx="10668000" cy="552450"/>
-          </a:xfrm>
-          <a:prstGeom xmlns:a="http://schemas.openxmlformats.org/drawingml/2006/main" prst="rect">
-            <a:avLst/>
-          </a:prstGeom>
-          <a:noFill xmlns:a="http://schemas.openxmlformats.org/drawingml/2006/main"/>
-          <a:ln xmlns:a="http://schemas.openxmlformats.org/drawingml/2006/main" w="0">
-            <a:noFill/>
-          </a:ln>
-        </p:spPr>
-        <p:txBody>
-          <a:bodyPr xmlns:a="http://schemas.openxmlformats.org/drawingml/2006/main" anchor="t">
-            <a:noAutofit/>
-          </a:bodyPr>
-          <a:lstStyle xmlns:a="http://schemas.openxmlformats.org/drawingml/2006/main"/>
-          <a:p xmlns:a="http://schemas.openxmlformats.org/drawingml/2006/main">
-            <a:pPr>
-              <a:defRPr sz="2100" b="1">
-                <a:solidFill>
                   <a:srgbClr val="986224"/>
                 </a:solidFill>
                 <a:latin typeface="Arial"/>
                 <a:ea typeface="Arial"/>
                 <a:cs typeface="Arial"/>
-              </a:defRPr>
-            </a:pPr>
-            <a:r>
-              <a:rPr sz="2100" b="1">
+              </a:rPr>
+              <a:t>Still unverified</a:t>
+            </a:r>
+          </a:p>
+        </p:txBody>
+      </p:sp>
+      <p:sp>
+        <p:nvSpPr>
+          <p:cNvPr id="10" name="">
+            <a:extLst xmlns:a="http://schemas.openxmlformats.org/drawingml/2006/main">
+              <a:ext uri="{FF2B5EF4-FFF2-40B4-BE49-F238E27FC236}">
+                <a16:creationId xmlns:a16="http://schemas.microsoft.com/office/drawing/2014/main" id="{6BD96BBF-52BB-4042-9856-527898F42E23}"/>
+              </a:ext>
+            </a:extLst>
+          </p:cNvPr>
+          <p:cNvSpPr>
+            <a:spLocks xmlns:a="http://schemas.openxmlformats.org/drawingml/2006/main" noGrp="1"/>
+          </p:cNvSpPr>
+          <p:nvPr/>
+        </p:nvSpPr>
+        <p:spPr>
+          <a:xfrm xmlns:a="http://schemas.openxmlformats.org/drawingml/2006/main">
+            <a:off x="704850" y="5486400"/>
+            <a:ext cx="10763250" cy="752475"/>
+          </a:xfrm>
+          <a:prstGeom xmlns:a="http://schemas.openxmlformats.org/drawingml/2006/main" prst="rect">
+            <a:avLst/>
+          </a:prstGeom>
+          <a:noFill xmlns:a="http://schemas.openxmlformats.org/drawingml/2006/main"/>
+          <a:ln xmlns:a="http://schemas.openxmlformats.org/drawingml/2006/main" w="0">
+            <a:noFill/>
+          </a:ln>
+        </p:spPr>
+        <p:txBody>
+          <a:bodyPr xmlns:a="http://schemas.openxmlformats.org/drawingml/2006/main" anchor="t">
+            <a:noAutofit/>
+          </a:bodyPr>
+          <a:lstStyle xmlns:a="http://schemas.openxmlformats.org/drawingml/2006/main"/>
+          <a:p xmlns:a="http://schemas.openxmlformats.org/drawingml/2006/main">
+            <a:pPr>
+              <a:defRPr sz="1950" b="0">
                 <a:solidFill>
                   <a:srgbClr val="986224"/>
                 </a:solidFill>
                 <a:latin typeface="Arial"/>
                 <a:ea typeface="Arial"/>
                 <a:cs typeface="Arial"/>
-              </a:rPr>
-              <a:t>Blocked: the configured API account has no credit (HTTP 429).</a:t>
-            </a:r>
-          </a:p>
-        </p:txBody>
-      </p:sp>
-      <p:sp>
-        <p:nvSpPr>
-          <p:cNvPr id="9" name="">
-            <a:extLst xmlns:a="http://schemas.openxmlformats.org/drawingml/2006/main">
-              <a:ext uri="{FF2B5EF4-FFF2-40B4-BE49-F238E27FC236}">
-                <a16:creationId xmlns:a16="http://schemas.microsoft.com/office/drawing/2014/main" id="{CE18FDA1-4581-4D1A-A0BE-496410345C5A}"/>
-              </a:ext>
-            </a:extLst>
-          </p:cNvPr>
-          <p:cNvSpPr>
-            <a:spLocks xmlns:a="http://schemas.openxmlformats.org/drawingml/2006/main" noGrp="1"/>
-          </p:cNvSpPr>
-          <p:nvPr/>
-        </p:nvSpPr>
-        <p:spPr>
-          <a:xfrm xmlns:a="http://schemas.openxmlformats.org/drawingml/2006/main">
-            <a:off x="704850" y="4533900"/>
-            <a:ext cx="10668000" cy="428625"/>
-          </a:xfrm>
-          <a:prstGeom xmlns:a="http://schemas.openxmlformats.org/drawingml/2006/main" prst="rect">
-            <a:avLst/>
-          </a:prstGeom>
-          <a:noFill xmlns:a="http://schemas.openxmlformats.org/drawingml/2006/main"/>
-          <a:ln xmlns:a="http://schemas.openxmlformats.org/drawingml/2006/main" w="0">
-            <a:noFill/>
-          </a:ln>
-        </p:spPr>
-        <p:txBody>
-          <a:bodyPr xmlns:a="http://schemas.openxmlformats.org/drawingml/2006/main" anchor="t">
-            <a:noAutofit/>
-          </a:bodyPr>
-          <a:lstStyle xmlns:a="http://schemas.openxmlformats.org/drawingml/2006/main"/>
-          <a:p xmlns:a="http://schemas.openxmlformats.org/drawingml/2006/main">
-            <a:pPr>
-              <a:defRPr sz="2325" b="1">
-                <a:solidFill>
-                  <a:srgbClr val="1B5147"/>
-                </a:solidFill>
-                <a:latin typeface="Arial"/>
-                <a:ea typeface="Arial"/>
-                <a:cs typeface="Arial"/>
-              </a:defRPr>
-            </a:pPr>
-            <a:r>
-              <a:rPr sz="2325" b="1">
-                <a:solidFill>
-                  <a:srgbClr val="1B5147"/>
-                </a:solidFill>
-                <a:latin typeface="Arial"/>
-                <a:ea typeface="Arial"/>
-                <a:cs typeface="Arial"/>
-              </a:rPr>
-              <a:t>Korean microphone and audible Realtime speech</a:t>
-            </a:r>
-          </a:p>
-        </p:txBody>
-      </p:sp>
-      <p:sp>
-        <p:nvSpPr>
-          <p:cNvPr id="10" name="">
-            <a:extLst xmlns:a="http://schemas.openxmlformats.org/drawingml/2006/main">
-              <a:ext uri="{FF2B5EF4-FFF2-40B4-BE49-F238E27FC236}">
-                <a16:creationId xmlns:a16="http://schemas.microsoft.com/office/drawing/2014/main" id="{D6B1046E-57B1-4DF3-B98B-5E1974DF2768}"/>
-              </a:ext>
-            </a:extLst>
-          </p:cNvPr>
-          <p:cNvSpPr>
-            <a:spLocks xmlns:a="http://schemas.openxmlformats.org/drawingml/2006/main" noGrp="1"/>
-          </p:cNvSpPr>
-          <p:nvPr/>
-        </p:nvSpPr>
-        <p:spPr>
-          <a:xfrm xmlns:a="http://schemas.openxmlformats.org/drawingml/2006/main">
-            <a:off x="704850" y="5010150"/>
-            <a:ext cx="10668000" cy="514350"/>
-          </a:xfrm>
-          <a:prstGeom xmlns:a="http://schemas.openxmlformats.org/drawingml/2006/main" prst="rect">
-            <a:avLst/>
-          </a:prstGeom>
-          <a:noFill xmlns:a="http://schemas.openxmlformats.org/drawingml/2006/main"/>
-          <a:ln xmlns:a="http://schemas.openxmlformats.org/drawingml/2006/main" w="0">
-            <a:noFill/>
-          </a:ln>
-        </p:spPr>
-        <p:txBody>
-          <a:bodyPr xmlns:a="http://schemas.openxmlformats.org/drawingml/2006/main" anchor="t">
-            <a:noAutofit/>
-          </a:bodyPr>
-          <a:lstStyle xmlns:a="http://schemas.openxmlformats.org/drawingml/2006/main"/>
-          <a:p xmlns:a="http://schemas.openxmlformats.org/drawingml/2006/main">
-            <a:pPr>
-              <a:defRPr sz="2100" b="1">
+              </a:defRPr>
+            </a:pPr>
+            <a:r>
+              <a:rPr sz="1950" b="0">
                 <a:solidFill>
                   <a:srgbClr val="986224"/>
                 </a:solidFill>
                 <a:latin typeface="Arial"/>
                 <a:ea typeface="Arial"/>
                 <a:cs typeface="Arial"/>
-              </a:defRPr>
-            </a:pPr>
-            <a:r>
-              <a:rPr sz="2100" b="1">
+              </a:rPr>
+              <a:t>Live unknown-detail relay and normal completion: Unverified.</a:t>
+            </a:r>
+          </a:p>
+          <a:p xmlns:a="http://schemas.openxmlformats.org/drawingml/2006/main">
+            <a:pPr>
+              <a:defRPr sz="1950" b="0">
                 <a:solidFill>
                   <a:srgbClr val="986224"/>
                 </a:solidFill>
                 <a:latin typeface="Arial"/>
                 <a:ea typeface="Arial"/>
                 <a:cs typeface="Arial"/>
-              </a:rPr>
-              <a:t>Unverified: no completed live microphone and speaker run.</a:t>
-            </a:r>
-          </a:p>
-        </p:txBody>
-      </p:sp>
-      <p:sp>
-        <p:nvSpPr>
-          <p:cNvPr id="11" name="">
-            <a:extLst xmlns:a="http://schemas.openxmlformats.org/drawingml/2006/main">
-              <a:ext uri="{FF2B5EF4-FFF2-40B4-BE49-F238E27FC236}">
-                <a16:creationId xmlns:a16="http://schemas.microsoft.com/office/drawing/2014/main" id="{5548149E-5B6B-44B6-93F8-7443C2776D2E}"/>
-              </a:ext>
-            </a:extLst>
-          </p:cNvPr>
-          <p:cNvSpPr>
-            <a:spLocks xmlns:a="http://schemas.openxmlformats.org/drawingml/2006/main" noGrp="1"/>
-          </p:cNvSpPr>
-          <p:nvPr/>
-        </p:nvSpPr>
-        <p:spPr>
-          <a:xfrm xmlns:a="http://schemas.openxmlformats.org/drawingml/2006/main">
-            <a:off x="704850" y="5743575"/>
-            <a:ext cx="10763250" cy="514350"/>
-          </a:xfrm>
-          <a:prstGeom xmlns:a="http://schemas.openxmlformats.org/drawingml/2006/main" prst="rect">
-            <a:avLst/>
-          </a:prstGeom>
-          <a:noFill xmlns:a="http://schemas.openxmlformats.org/drawingml/2006/main"/>
-          <a:ln xmlns:a="http://schemas.openxmlformats.org/drawingml/2006/main" w="0">
-            <a:noFill/>
-          </a:ln>
-        </p:spPr>
-        <p:txBody>
-          <a:bodyPr xmlns:a="http://schemas.openxmlformats.org/drawingml/2006/main" anchor="t">
-            <a:noAutofit/>
-          </a:bodyPr>
-          <a:lstStyle xmlns:a="http://schemas.openxmlformats.org/drawingml/2006/main"/>
-          <a:p xmlns:a="http://schemas.openxmlformats.org/drawingml/2006/main">
-            <a:pPr>
-              <a:defRPr sz="1650" b="0">
-                <a:solidFill>
-                  <a:srgbClr val="64756D"/>
-                </a:solidFill>
-                <a:latin typeface="Arial"/>
-                <a:ea typeface="Arial"/>
-                <a:cs typeface="Arial"/>
-              </a:defRPr>
-            </a:pPr>
-            <a:r>
-              <a:rPr sz="1650" b="0">
-                <a:solidFill>
-                  <a:srgbClr val="64756D"/>
-                </a:solidFill>
-                <a:latin typeface="Arial"/>
-                <a:ea typeface="Arial"/>
-                <a:cs typeface="Arial"/>
-              </a:rPr>
-              <a:t>Codex built call-state rules and UI checks. We tested connection loss,</a:t>
-            </a:r>
-          </a:p>
-          <a:p xmlns:a="http://schemas.openxmlformats.org/drawingml/2006/main">
-            <a:pPr>
-              <a:defRPr sz="1650" b="0">
-                <a:solidFill>
-                  <a:srgbClr val="64756D"/>
-                </a:solidFill>
-                <a:latin typeface="Arial"/>
-                <a:ea typeface="Arial"/>
-                <a:cs typeface="Arial"/>
-              </a:defRPr>
-            </a:pPr>
-            <a:r>
-              <a:rPr sz="1650" b="0">
-                <a:solidFill>
-                  <a:srgbClr val="64756D"/>
-                </a:solidFill>
-                <a:latin typeface="Arial"/>
-                <a:ea typeface="Arial"/>
-                <a:cs typeface="Arial"/>
-              </a:rPr>
-              <a:t>unknown-detail relay, and incomplete endings against explicit expectations.</a:t>
+              </a:defRPr>
+            </a:pPr>
+            <a:r>
+              <a:rPr sz="1950" b="0">
+                <a:solidFill>
+                  <a:srgbClr val="986224"/>
+                </a:solidFill>
+                <a:latin typeface="Arial"/>
+                <a:ea typeface="Arial"/>
+                <a:cs typeface="Arial"/>
+              </a:rPr>
+              <a:t>Russian/Chinese interviews exercised; fidelity limits remain.</a:t>
             </a:r>
           </a:p>
         </p:txBody>
@@ -4364,7 +4353,7 @@
     </p:spTree>
     <p:extLst>
       <p:ext uri="{BB962C8B-B14F-4D97-AF65-F5344CB8AC3E}">
-        <p14:creationId xmlns:p14="http://schemas.microsoft.com/office/powerpoint/2010/main" val="1971482680"/>
+        <p14:creationId xmlns:p14="http://schemas.microsoft.com/office/powerpoint/2010/main" val="1759203769"/>
       </p:ext>
     </p:extLst>
   </p:cSld>
@@ -4395,7 +4384,7 @@
           <p:cNvPr id="9" name="">
             <a:extLst xmlns:a="http://schemas.openxmlformats.org/drawingml/2006/main">
               <a:ext uri="{FF2B5EF4-FFF2-40B4-BE49-F238E27FC236}">
-                <a16:creationId xmlns:a16="http://schemas.microsoft.com/office/drawing/2014/main" id="{BAEBECED-6619-4D49-A7E0-27C5BADD345F}"/>
+                <a16:creationId xmlns:a16="http://schemas.microsoft.com/office/drawing/2014/main" id="{B672884A-EAA1-479F-A796-D90AFA56487F}"/>
               </a:ext>
             </a:extLst>
           </p:cNvPr>
@@ -4452,7 +4441,7 @@
           <p:cNvPr id="2" name="">
             <a:extLst xmlns:a="http://schemas.openxmlformats.org/drawingml/2006/main">
               <a:ext uri="{FF2B5EF4-FFF2-40B4-BE49-F238E27FC236}">
-                <a16:creationId xmlns:a16="http://schemas.microsoft.com/office/drawing/2014/main" id="{D2B74757-85F2-4C90-A5CF-37DDF9701C7B}"/>
+                <a16:creationId xmlns:a16="http://schemas.microsoft.com/office/drawing/2014/main" id="{B2EBA36D-EEDB-4662-B661-E0C90D5707B7}"/>
               </a:ext>
             </a:extLst>
           </p:cNvPr>
@@ -4509,7 +4498,7 @@
           <p:cNvPr id="3" name="">
             <a:extLst xmlns:a="http://schemas.openxmlformats.org/drawingml/2006/main">
               <a:ext uri="{FF2B5EF4-FFF2-40B4-BE49-F238E27FC236}">
-                <a16:creationId xmlns:a16="http://schemas.microsoft.com/office/drawing/2014/main" id="{3C19B69C-2B41-4B4B-BD52-A557D77D2B01}"/>
+                <a16:creationId xmlns:a16="http://schemas.microsoft.com/office/drawing/2014/main" id="{12F3F7E2-661F-431F-85B9-8825EF61E3B5}"/>
               </a:ext>
             </a:extLst>
           </p:cNvPr>
@@ -4566,7 +4555,7 @@
           <p:cNvPr id="4" name="">
             <a:extLst xmlns:a="http://schemas.openxmlformats.org/drawingml/2006/main">
               <a:ext uri="{FF2B5EF4-FFF2-40B4-BE49-F238E27FC236}">
-                <a16:creationId xmlns:a16="http://schemas.microsoft.com/office/drawing/2014/main" id="{BA5A686C-ABA3-4CB8-A7CE-9037C6D9C3B0}"/>
+                <a16:creationId xmlns:a16="http://schemas.microsoft.com/office/drawing/2014/main" id="{A78346E7-714F-4418-B730-5577D7CA7B81}"/>
               </a:ext>
             </a:extLst>
           </p:cNvPr>
@@ -4646,7 +4635,7 @@
           <p:cNvPr id="5" name="">
             <a:extLst xmlns:a="http://schemas.openxmlformats.org/drawingml/2006/main">
               <a:ext uri="{FF2B5EF4-FFF2-40B4-BE49-F238E27FC236}">
-                <a16:creationId xmlns:a16="http://schemas.microsoft.com/office/drawing/2014/main" id="{7C4CCC10-1D2B-41F5-BDE3-60FE6D0DBB6B}"/>
+                <a16:creationId xmlns:a16="http://schemas.microsoft.com/office/drawing/2014/main" id="{5FBEC121-3FDC-4DCE-9CDE-6449E54DBF35}"/>
               </a:ext>
             </a:extLst>
           </p:cNvPr>
@@ -4703,7 +4692,7 @@
           <p:cNvPr id="6" name="">
             <a:extLst xmlns:a="http://schemas.openxmlformats.org/drawingml/2006/main">
               <a:ext uri="{FF2B5EF4-FFF2-40B4-BE49-F238E27FC236}">
-                <a16:creationId xmlns:a16="http://schemas.microsoft.com/office/drawing/2014/main" id="{DA7FC24C-F5B3-43AA-845B-C19927470BB1}"/>
+                <a16:creationId xmlns:a16="http://schemas.microsoft.com/office/drawing/2014/main" id="{8D93B7C2-8759-4E07-8E6F-D3758A8E064B}"/>
               </a:ext>
             </a:extLst>
           </p:cNvPr>
@@ -4760,7 +4749,7 @@
           <p:cNvPr id="7" name="">
             <a:extLst xmlns:a="http://schemas.openxmlformats.org/drawingml/2006/main">
               <a:ext uri="{FF2B5EF4-FFF2-40B4-BE49-F238E27FC236}">
-                <a16:creationId xmlns:a16="http://schemas.microsoft.com/office/drawing/2014/main" id="{77F85AA1-B41B-4E91-8777-D340ED1BED97}"/>
+                <a16:creationId xmlns:a16="http://schemas.microsoft.com/office/drawing/2014/main" id="{9E9A3261-8244-4344-8212-8F812E60EFC4}"/>
               </a:ext>
             </a:extLst>
           </p:cNvPr>
@@ -4817,7 +4806,7 @@
           <p:cNvPr id="8" name="">
             <a:extLst xmlns:a="http://schemas.openxmlformats.org/drawingml/2006/main">
               <a:ext uri="{FF2B5EF4-FFF2-40B4-BE49-F238E27FC236}">
-                <a16:creationId xmlns:a16="http://schemas.microsoft.com/office/drawing/2014/main" id="{202083AE-6BA0-4372-BE7F-10D198682A9C}"/>
+                <a16:creationId xmlns:a16="http://schemas.microsoft.com/office/drawing/2014/main" id="{6A99D211-A7C3-40C3-8833-FDD61A0CC51A}"/>
               </a:ext>
             </a:extLst>
           </p:cNvPr>
@@ -4895,7 +4884,7 @@
     </p:spTree>
     <p:extLst>
       <p:ext uri="{BB962C8B-B14F-4D97-AF65-F5344CB8AC3E}">
-        <p14:creationId xmlns:p14="http://schemas.microsoft.com/office/powerpoint/2010/main" val="2057827151"/>
+        <p14:creationId xmlns:p14="http://schemas.microsoft.com/office/powerpoint/2010/main" val="1328362818"/>
       </p:ext>
     </p:extLst>
   </p:cSld>

</xml_diff>

<commit_message>
Preserve post-62f9a09 voice repairs and verification evidence
</commit_message>
<xml_diff>
--- a/submission/v2/slides.pptx
+++ b/submission/v2/slides.pptx
@@ -2,17 +2,17 @@
 <file path=ppt/presentation.xml><?xml version="1.0" encoding="utf-8"?>
 <p:presentation xmlns:p="http://schemas.openxmlformats.org/presentationml/2006/main">
   <p:sldMasterIdLst>
-    <p:sldMasterId xmlns:r="http://schemas.openxmlformats.org/officeDocument/2006/relationships" id="2147483648" r:id="R1732f969247142ba"/>
+    <p:sldMasterId xmlns:r="http://schemas.openxmlformats.org/officeDocument/2006/relationships" id="2147483648" r:id="R8d4f54d3bd1a429c"/>
   </p:sldMasterIdLst>
   <p:notesMasterIdLst>
-    <p:notesMasterId xmlns:r="http://schemas.openxmlformats.org/officeDocument/2006/relationships" r:id="R75f1cff8defa483f"/>
+    <p:notesMasterId xmlns:r="http://schemas.openxmlformats.org/officeDocument/2006/relationships" r:id="R24760e2fa7f94644"/>
   </p:notesMasterIdLst>
   <p:sldIdLst>
-    <p:sldId xmlns:r="http://schemas.openxmlformats.org/officeDocument/2006/relationships" id="256" r:id="R79c6a600a72947d1"/>
-    <p:sldId xmlns:r="http://schemas.openxmlformats.org/officeDocument/2006/relationships" id="257" r:id="R97d35868662d4bde"/>
-    <p:sldId xmlns:r="http://schemas.openxmlformats.org/officeDocument/2006/relationships" id="258" r:id="Rac3d6698052d4e32"/>
-    <p:sldId xmlns:r="http://schemas.openxmlformats.org/officeDocument/2006/relationships" id="259" r:id="R5f840bbd5bf347ac"/>
-    <p:sldId xmlns:r="http://schemas.openxmlformats.org/officeDocument/2006/relationships" id="260" r:id="R546dc1a600394804"/>
+    <p:sldId xmlns:r="http://schemas.openxmlformats.org/officeDocument/2006/relationships" id="256" r:id="R815042900d0640e7"/>
+    <p:sldId xmlns:r="http://schemas.openxmlformats.org/officeDocument/2006/relationships" id="257" r:id="Rfbf422c315bb456c"/>
+    <p:sldId xmlns:r="http://schemas.openxmlformats.org/officeDocument/2006/relationships" id="258" r:id="Rcc4873ec3d894ce3"/>
+    <p:sldId xmlns:r="http://schemas.openxmlformats.org/officeDocument/2006/relationships" id="259" r:id="Rf433d52a9ee74507"/>
+    <p:sldId xmlns:r="http://schemas.openxmlformats.org/officeDocument/2006/relationships" id="260" r:id="R47995446ee104053"/>
   </p:sldIdLst>
   <p:sldSz cx="12192000" cy="6858000"/>
   <p:notesSz cx="6858000" cy="9144000"/>
@@ -601,7 +601,7 @@
           </a:p>
           <a:p xmlns:a="http://schemas.openxmlformats.org/drawingml/2006/main">
             <a:r>
-              <a:t>0:55–2:00. Open a separate business tab on the same laptop. It must remain inactive before customer authorization. Accept only when incoming. Use fictional customer details and business answers. Choose an unknown customer detail based on the actual interview, rather than assuming prior-visit status is unknown. The third actual rehearsal captured four business answers and a readback, but confirmation reset the answers and the teammate disconnected. Unknown-detail relay and a normal completed call remain unverified. Demonstrate these steps only if a new real run actually reaches them.</a:t>
+              <a:t>0:55–2:00. The current shop example requests a navy waterproof daypack of about 20 litres, any brand, in Mapo for evening pickup. A bounded real API interview prepared stock, price and closing/pickup questions; six provider responses, two customer turns. The price question says available before stock is confirmed, a disclosed wording limitation. No stock, price or hours are established. The actual shop room accepted at 15:12:16 KST and received the full Korean opening and stock question. The operator ended at 15:15:45 after unsupported stock/price classification and a microphone stall. Human audibility is not confirmed. Source: artifacts/v2/live-shop-first-attempt.json. Ask conditionally whether black would be acceptable; never assume the preference. Source: artifacts/v2/live-shop-plan-check.json; docs/v2-shop-demo.md. Open a separate business tab on the same laptop. It must remain inactive before customer authorization. Accept only when incoming. Use fictional customer details and business answers. Choose an unknown customer detail based on the actual interview, rather than assuming prior-visit status is unknown. The third actual rehearsal captured four business answers and a readback, but confirmation reset the answers and the teammate disconnected. Unknown-detail relay and a normal completed call remain unverified. Demonstrate these steps only if a new real run actually reaches them.</a:t>
             </a:r>
           </a:p>
         </p:txBody>
@@ -676,7 +676,7 @@
           </a:p>
           <a:p xmlns:a="http://schemas.openxmlformats.org/drawingml/2006/main">
             <a:r>
-              <a:t>2:00–2:30. The current code checkpoint has 57 local tests, 17 local HTTP checks, 20 mocked customer browser checks, and 11 mocked business browser checks. These are different evidence classes. The third real laptop microphone run captured four actual Korean business answers and an assistant readback, including qualified cost uncertainty. Business confirmation incorrectly reset the resolved state; the human disconnected. Korean audibility was human-confirmed in the first attempt only. Unknown-detail relay was not exercised in the third attempt. Later readback fixes require another live rehearsal. Real Russian and Chinese interviews were exercised, but Korean question fidelity and unsupported first-visit wording remain limited. Sources: artifacts/v2/live-native-rehearsal-third-attempt.json; artifacts/v2/live-native-third-attempt-audit.json; artifacts/v2/customer-ui-check.json; docs/v2-verification.md. These local evidence files are not raw material for the official upload.</a:t>
+              <a:t>2:00–2:30. The current code checkpoint has 63 local tests (31 state, 17 guard, 15 legacy), 23 actual local HTTP checks with synthetic setup plans and upstream network blocked, 20 mocked customer browser checks, and 14 mocked business browser checks. These are different evidence classes. The third real laptop microphone run captured four actual Korean business answers and an assistant readback, including qualified cost uncertainty. Business confirmation incorrectly reset the resolved state; the human disconnected. Korean audibility was human-confirmed in the first attempt only. Unknown-detail relay was not exercised in the third attempt. Later readback and startup fixes require another live rehearsal. Startup now waits for session.created, a remote track and connection registration, sends one tool-free opening, and pauses the microphone through completed playback and playback permission; missing opening audio fails after 12 seconds. The new shop opening audio started at 15:12:19.502 and its full greeting/stock-question transcript was captured, but human audibility is not confirmed. Only a business greeting and apology were transcribed. The review incorrectly classified those as negative stock and unavailable price; that unsupported state also entered the summary. Consecutive responses left the microphone paused; the operator ended at 15:15:45. Repairs are pending, and no live relay or normal completion is claimed. Source: artifacts/v2/live-shop-first-attempt.json. A separate recorded-text summary regression passed 9/9 using one real structured recommendation request. The AI chose an allowed action and existing answer references; rendering preserved the original interrupted outcome and qualified price, without new microphone or audio evidence. Source: artifacts/v2/recorded-third-typed-summary-check.json. Real Russian and Chinese interviews were exercised, but Korean question fidelity and unsupported first-visit wording remain limited. Sources: artifacts/v2/live-native-rehearsal-third-attempt.json; artifacts/v2/live-native-third-attempt-audit.json; artifacts/v2/customer-ui-check.json; docs/v2-verification.md. These local evidence files are not raw material for the official upload.</a:t>
             </a:r>
           </a:p>
         </p:txBody>
@@ -819,7 +819,7 @@
   </p:cSld>
   <p:clrMap bg1="lt1" tx1="dk1" bg2="lt2" tx2="dk2" accent1="accent1" accent2="accent2" accent3="accent3" accent4="accent4" accent5="accent5" accent6="accent6" hlink="hlink" folHlink="folHlink"/>
   <p:sldLayoutIdLst>
-    <p:sldLayoutId xmlns:r="http://schemas.openxmlformats.org/officeDocument/2006/relationships" id="2147483649" r:id="R0e273f56b4ea4acb"/>
+    <p:sldLayoutId xmlns:r="http://schemas.openxmlformats.org/officeDocument/2006/relationships" id="2147483649" r:id="R0bf819929ebf4c8a"/>
   </p:sldLayoutIdLst>
   <p:txStyles>
     <p:titleStyle>
@@ -1370,7 +1370,7 @@
           <p:cNvPr id="7" name="">
             <a:extLst xmlns:a="http://schemas.openxmlformats.org/drawingml/2006/main">
               <a:ext uri="{FF2B5EF4-FFF2-40B4-BE49-F238E27FC236}">
-                <a16:creationId xmlns:a16="http://schemas.microsoft.com/office/drawing/2014/main" id="{0B10F6D8-A84C-4E3E-9055-99564B9060C2}"/>
+                <a16:creationId xmlns:a16="http://schemas.microsoft.com/office/drawing/2014/main" id="{B874A44B-6DF7-421C-B82A-AC85DE8549CE}"/>
               </a:ext>
             </a:extLst>
           </p:cNvPr>
@@ -1427,7 +1427,7 @@
           <p:cNvPr id="2" name="">
             <a:extLst xmlns:a="http://schemas.openxmlformats.org/drawingml/2006/main">
               <a:ext uri="{FF2B5EF4-FFF2-40B4-BE49-F238E27FC236}">
-                <a16:creationId xmlns:a16="http://schemas.microsoft.com/office/drawing/2014/main" id="{DC2A8840-16A9-4379-B089-AA3496F3EF92}"/>
+                <a16:creationId xmlns:a16="http://schemas.microsoft.com/office/drawing/2014/main" id="{223343EA-E8FC-4E60-931E-BBF99F3CE7F5}"/>
               </a:ext>
             </a:extLst>
           </p:cNvPr>
@@ -1484,7 +1484,7 @@
           <p:cNvPr id="3" name="">
             <a:extLst xmlns:a="http://schemas.openxmlformats.org/drawingml/2006/main">
               <a:ext uri="{FF2B5EF4-FFF2-40B4-BE49-F238E27FC236}">
-                <a16:creationId xmlns:a16="http://schemas.microsoft.com/office/drawing/2014/main" id="{4D120FD0-7B08-45F1-B83F-12441D5FF386}"/>
+                <a16:creationId xmlns:a16="http://schemas.microsoft.com/office/drawing/2014/main" id="{0942959A-0236-49C1-8318-653FF18C98BB}"/>
               </a:ext>
             </a:extLst>
           </p:cNvPr>
@@ -1541,7 +1541,7 @@
           <p:cNvPr id="4" name="">
             <a:extLst xmlns:a="http://schemas.openxmlformats.org/drawingml/2006/main">
               <a:ext uri="{FF2B5EF4-FFF2-40B4-BE49-F238E27FC236}">
-                <a16:creationId xmlns:a16="http://schemas.microsoft.com/office/drawing/2014/main" id="{B55FF9D0-B6FA-457B-B997-144F92834DC0}"/>
+                <a16:creationId xmlns:a16="http://schemas.microsoft.com/office/drawing/2014/main" id="{F50FF05C-4142-4673-A4A1-21B418DD852A}"/>
               </a:ext>
             </a:extLst>
           </p:cNvPr>
@@ -1621,7 +1621,7 @@
           <p:cNvPr id="5" name="">
             <a:extLst xmlns:a="http://schemas.openxmlformats.org/drawingml/2006/main">
               <a:ext uri="{FF2B5EF4-FFF2-40B4-BE49-F238E27FC236}">
-                <a16:creationId xmlns:a16="http://schemas.microsoft.com/office/drawing/2014/main" id="{A55C45B0-788B-47A9-95D6-41FD1EB0AD05}"/>
+                <a16:creationId xmlns:a16="http://schemas.microsoft.com/office/drawing/2014/main" id="{A080D3EF-1AAB-4B39-B440-0758D5BE1BD5}"/>
               </a:ext>
             </a:extLst>
           </p:cNvPr>
@@ -1701,7 +1701,7 @@
           <p:cNvPr id="6" name="">
             <a:extLst xmlns:a="http://schemas.openxmlformats.org/drawingml/2006/main">
               <a:ext uri="{FF2B5EF4-FFF2-40B4-BE49-F238E27FC236}">
-                <a16:creationId xmlns:a16="http://schemas.microsoft.com/office/drawing/2014/main" id="{FA3C3B6E-1613-4D2D-82E2-035E5A01D9F9}"/>
+                <a16:creationId xmlns:a16="http://schemas.microsoft.com/office/drawing/2014/main" id="{094F947F-A174-4275-B395-DF12208C775D}"/>
               </a:ext>
             </a:extLst>
           </p:cNvPr>
@@ -1779,7 +1779,7 @@
     </p:spTree>
     <p:extLst>
       <p:ext uri="{BB962C8B-B14F-4D97-AF65-F5344CB8AC3E}">
-        <p14:creationId xmlns:p14="http://schemas.microsoft.com/office/powerpoint/2010/main" val="151634298"/>
+        <p14:creationId xmlns:p14="http://schemas.microsoft.com/office/powerpoint/2010/main" val="278343163"/>
       </p:ext>
     </p:extLst>
   </p:cSld>
@@ -1810,7 +1810,7 @@
           <p:cNvPr id="19" name="">
             <a:extLst xmlns:a="http://schemas.openxmlformats.org/drawingml/2006/main">
               <a:ext uri="{FF2B5EF4-FFF2-40B4-BE49-F238E27FC236}">
-                <a16:creationId xmlns:a16="http://schemas.microsoft.com/office/drawing/2014/main" id="{EE13DAF3-E77B-46F2-B59C-B37F6CF39C3C}"/>
+                <a16:creationId xmlns:a16="http://schemas.microsoft.com/office/drawing/2014/main" id="{85798F62-BC4A-4D43-9854-25D04D0C2BBC}"/>
               </a:ext>
             </a:extLst>
           </p:cNvPr>
@@ -1867,7 +1867,7 @@
           <p:cNvPr id="2" name="">
             <a:extLst xmlns:a="http://schemas.openxmlformats.org/drawingml/2006/main">
               <a:ext uri="{FF2B5EF4-FFF2-40B4-BE49-F238E27FC236}">
-                <a16:creationId xmlns:a16="http://schemas.microsoft.com/office/drawing/2014/main" id="{581FB833-2D61-4C91-9684-2BFBCF0924EA}"/>
+                <a16:creationId xmlns:a16="http://schemas.microsoft.com/office/drawing/2014/main" id="{19E2B18B-A536-4C28-9812-8E2B21320DA2}"/>
               </a:ext>
             </a:extLst>
           </p:cNvPr>
@@ -1924,7 +1924,7 @@
           <p:cNvPr id="3" name="">
             <a:extLst xmlns:a="http://schemas.openxmlformats.org/drawingml/2006/main">
               <a:ext uri="{FF2B5EF4-FFF2-40B4-BE49-F238E27FC236}">
-                <a16:creationId xmlns:a16="http://schemas.microsoft.com/office/drawing/2014/main" id="{B1B81C7E-B673-4695-A80A-CED30CFC5C51}"/>
+                <a16:creationId xmlns:a16="http://schemas.microsoft.com/office/drawing/2014/main" id="{92E82C12-4129-4431-A9E8-C738F5A72C1D}"/>
               </a:ext>
             </a:extLst>
           </p:cNvPr>
@@ -1981,7 +1981,7 @@
           <p:cNvPr id="4" name="">
             <a:extLst xmlns:a="http://schemas.openxmlformats.org/drawingml/2006/main">
               <a:ext uri="{FF2B5EF4-FFF2-40B4-BE49-F238E27FC236}">
-                <a16:creationId xmlns:a16="http://schemas.microsoft.com/office/drawing/2014/main" id="{2F55C80D-639F-4859-8450-99C77C769870}"/>
+                <a16:creationId xmlns:a16="http://schemas.microsoft.com/office/drawing/2014/main" id="{269B045A-979E-4AE6-A0F8-674D21D005DE}"/>
               </a:ext>
             </a:extLst>
           </p:cNvPr>
@@ -2038,7 +2038,7 @@
           <p:cNvPr id="5" name="">
             <a:extLst xmlns:a="http://schemas.openxmlformats.org/drawingml/2006/main">
               <a:ext uri="{FF2B5EF4-FFF2-40B4-BE49-F238E27FC236}">
-                <a16:creationId xmlns:a16="http://schemas.microsoft.com/office/drawing/2014/main" id="{9F90DC65-FFD7-4DE4-8B8F-88AA8CC02EED}"/>
+                <a16:creationId xmlns:a16="http://schemas.microsoft.com/office/drawing/2014/main" id="{863763D3-10FE-4D8E-95C5-3FB632B2D60A}"/>
               </a:ext>
             </a:extLst>
           </p:cNvPr>
@@ -2095,7 +2095,7 @@
           <p:cNvPr id="6" name="">
             <a:extLst xmlns:a="http://schemas.openxmlformats.org/drawingml/2006/main">
               <a:ext uri="{FF2B5EF4-FFF2-40B4-BE49-F238E27FC236}">
-                <a16:creationId xmlns:a16="http://schemas.microsoft.com/office/drawing/2014/main" id="{7596CED8-D9FE-4BA0-BDF0-AB8192C81DA8}"/>
+                <a16:creationId xmlns:a16="http://schemas.microsoft.com/office/drawing/2014/main" id="{5B9EE51B-FD72-4F7A-8C21-0833075C421D}"/>
               </a:ext>
             </a:extLst>
           </p:cNvPr>
@@ -2152,7 +2152,7 @@
           <p:cNvPr id="7" name="">
             <a:extLst xmlns:a="http://schemas.openxmlformats.org/drawingml/2006/main">
               <a:ext uri="{FF2B5EF4-FFF2-40B4-BE49-F238E27FC236}">
-                <a16:creationId xmlns:a16="http://schemas.microsoft.com/office/drawing/2014/main" id="{2A9D09B8-421F-4934-A094-548845039F5F}"/>
+                <a16:creationId xmlns:a16="http://schemas.microsoft.com/office/drawing/2014/main" id="{BD059D19-DFFA-4074-90D3-8D276647072A}"/>
               </a:ext>
             </a:extLst>
           </p:cNvPr>
@@ -2209,7 +2209,7 @@
           <p:cNvPr id="8" name="">
             <a:extLst xmlns:a="http://schemas.openxmlformats.org/drawingml/2006/main">
               <a:ext uri="{FF2B5EF4-FFF2-40B4-BE49-F238E27FC236}">
-                <a16:creationId xmlns:a16="http://schemas.microsoft.com/office/drawing/2014/main" id="{0718FE1E-A775-46BD-8905-FE3D7FFDA491}"/>
+                <a16:creationId xmlns:a16="http://schemas.microsoft.com/office/drawing/2014/main" id="{27A3F425-5704-41FE-822B-1140330EEA9C}"/>
               </a:ext>
             </a:extLst>
           </p:cNvPr>
@@ -2266,7 +2266,7 @@
           <p:cNvPr id="9" name="">
             <a:extLst xmlns:a="http://schemas.openxmlformats.org/drawingml/2006/main">
               <a:ext uri="{FF2B5EF4-FFF2-40B4-BE49-F238E27FC236}">
-                <a16:creationId xmlns:a16="http://schemas.microsoft.com/office/drawing/2014/main" id="{F9DABD12-BC51-4244-9DC0-79D9F379069A}"/>
+                <a16:creationId xmlns:a16="http://schemas.microsoft.com/office/drawing/2014/main" id="{B12DF5CC-F5EE-4BEF-9193-6FC83B899188}"/>
               </a:ext>
             </a:extLst>
           </p:cNvPr>
@@ -2323,7 +2323,7 @@
           <p:cNvPr id="10" name="">
             <a:extLst xmlns:a="http://schemas.openxmlformats.org/drawingml/2006/main">
               <a:ext uri="{FF2B5EF4-FFF2-40B4-BE49-F238E27FC236}">
-                <a16:creationId xmlns:a16="http://schemas.microsoft.com/office/drawing/2014/main" id="{0C381C49-1708-41E5-A360-B678C25E02B7}"/>
+                <a16:creationId xmlns:a16="http://schemas.microsoft.com/office/drawing/2014/main" id="{7D9190CF-68A1-4C8E-8EE1-6D7C9BF2839E}"/>
               </a:ext>
             </a:extLst>
           </p:cNvPr>
@@ -2380,7 +2380,7 @@
           <p:cNvPr id="11" name="">
             <a:extLst xmlns:a="http://schemas.openxmlformats.org/drawingml/2006/main">
               <a:ext uri="{FF2B5EF4-FFF2-40B4-BE49-F238E27FC236}">
-                <a16:creationId xmlns:a16="http://schemas.microsoft.com/office/drawing/2014/main" id="{54298888-12BB-4846-96FF-E2EDE32836D2}"/>
+                <a16:creationId xmlns:a16="http://schemas.microsoft.com/office/drawing/2014/main" id="{E3639FB3-662E-41E9-9692-57541F7AB435}"/>
               </a:ext>
             </a:extLst>
           </p:cNvPr>
@@ -2437,7 +2437,7 @@
           <p:cNvPr id="12" name="">
             <a:extLst xmlns:a="http://schemas.openxmlformats.org/drawingml/2006/main">
               <a:ext uri="{FF2B5EF4-FFF2-40B4-BE49-F238E27FC236}">
-                <a16:creationId xmlns:a16="http://schemas.microsoft.com/office/drawing/2014/main" id="{D79BF030-390B-4DDA-BCC1-FEE2426CE9EC}"/>
+                <a16:creationId xmlns:a16="http://schemas.microsoft.com/office/drawing/2014/main" id="{19372BCF-EE78-4FC3-BB4F-652AABDFD1B5}"/>
               </a:ext>
             </a:extLst>
           </p:cNvPr>
@@ -2494,7 +2494,7 @@
           <p:cNvPr id="13" name="">
             <a:extLst xmlns:a="http://schemas.openxmlformats.org/drawingml/2006/main">
               <a:ext uri="{FF2B5EF4-FFF2-40B4-BE49-F238E27FC236}">
-                <a16:creationId xmlns:a16="http://schemas.microsoft.com/office/drawing/2014/main" id="{90712DF0-88C4-44CC-B9C1-BBA72142B03B}"/>
+                <a16:creationId xmlns:a16="http://schemas.microsoft.com/office/drawing/2014/main" id="{CE95F9D7-CCB4-443D-A6A6-6E277CD6CFFF}"/>
               </a:ext>
             </a:extLst>
           </p:cNvPr>
@@ -2551,7 +2551,7 @@
           <p:cNvPr id="14" name="">
             <a:extLst xmlns:a="http://schemas.openxmlformats.org/drawingml/2006/main">
               <a:ext uri="{FF2B5EF4-FFF2-40B4-BE49-F238E27FC236}">
-                <a16:creationId xmlns:a16="http://schemas.microsoft.com/office/drawing/2014/main" id="{9C5F3527-4077-4BFB-A275-1EE0A4378B6D}"/>
+                <a16:creationId xmlns:a16="http://schemas.microsoft.com/office/drawing/2014/main" id="{CA9CB2F3-5EFF-4C93-A7C8-9EE63FFE7DF6}"/>
               </a:ext>
             </a:extLst>
           </p:cNvPr>
@@ -2608,7 +2608,7 @@
           <p:cNvPr id="15" name="">
             <a:extLst xmlns:a="http://schemas.openxmlformats.org/drawingml/2006/main">
               <a:ext uri="{FF2B5EF4-FFF2-40B4-BE49-F238E27FC236}">
-                <a16:creationId xmlns:a16="http://schemas.microsoft.com/office/drawing/2014/main" id="{84C0C6BE-7EB1-4733-A6BB-AABAF18EC4B8}"/>
+                <a16:creationId xmlns:a16="http://schemas.microsoft.com/office/drawing/2014/main" id="{75D8FFFF-00E3-4ABD-AF4B-0F04963D06BA}"/>
               </a:ext>
             </a:extLst>
           </p:cNvPr>
@@ -2665,7 +2665,7 @@
           <p:cNvPr id="16" name="">
             <a:extLst xmlns:a="http://schemas.openxmlformats.org/drawingml/2006/main">
               <a:ext uri="{FF2B5EF4-FFF2-40B4-BE49-F238E27FC236}">
-                <a16:creationId xmlns:a16="http://schemas.microsoft.com/office/drawing/2014/main" id="{23289220-0FD1-46E4-A73E-EAEB884FDDA5}"/>
+                <a16:creationId xmlns:a16="http://schemas.microsoft.com/office/drawing/2014/main" id="{B1A576A3-FB32-49A0-964D-77ACD42AA9CE}"/>
               </a:ext>
             </a:extLst>
           </p:cNvPr>
@@ -2722,7 +2722,7 @@
           <p:cNvPr id="17" name="">
             <a:extLst xmlns:a="http://schemas.openxmlformats.org/drawingml/2006/main">
               <a:ext uri="{FF2B5EF4-FFF2-40B4-BE49-F238E27FC236}">
-                <a16:creationId xmlns:a16="http://schemas.microsoft.com/office/drawing/2014/main" id="{7D888013-61B3-4C50-ADE1-3CF298FEFDA7}"/>
+                <a16:creationId xmlns:a16="http://schemas.microsoft.com/office/drawing/2014/main" id="{E14A6F62-1827-49A3-A97F-444D22395DA0}"/>
               </a:ext>
             </a:extLst>
           </p:cNvPr>
@@ -2779,7 +2779,7 @@
           <p:cNvPr id="18" name="">
             <a:extLst xmlns:a="http://schemas.openxmlformats.org/drawingml/2006/main">
               <a:ext uri="{FF2B5EF4-FFF2-40B4-BE49-F238E27FC236}">
-                <a16:creationId xmlns:a16="http://schemas.microsoft.com/office/drawing/2014/main" id="{4AC6027D-DC8E-471F-80F6-6A3777095EA6}"/>
+                <a16:creationId xmlns:a16="http://schemas.microsoft.com/office/drawing/2014/main" id="{E64FB2AE-B8FA-44A6-8898-E926A3E95F0B}"/>
               </a:ext>
             </a:extLst>
           </p:cNvPr>
@@ -2834,7 +2834,7 @@
     </p:spTree>
     <p:extLst>
       <p:ext uri="{BB962C8B-B14F-4D97-AF65-F5344CB8AC3E}">
-        <p14:creationId xmlns:p14="http://schemas.microsoft.com/office/powerpoint/2010/main" val="871903996"/>
+        <p14:creationId xmlns:p14="http://schemas.microsoft.com/office/powerpoint/2010/main" val="1708240104"/>
       </p:ext>
     </p:extLst>
   </p:cSld>
@@ -2865,7 +2865,7 @@
           <p:cNvPr id="13" name="">
             <a:extLst xmlns:a="http://schemas.openxmlformats.org/drawingml/2006/main">
               <a:ext uri="{FF2B5EF4-FFF2-40B4-BE49-F238E27FC236}">
-                <a16:creationId xmlns:a16="http://schemas.microsoft.com/office/drawing/2014/main" id="{06728005-1F95-4907-9688-DC5471EFDAC3}"/>
+                <a16:creationId xmlns:a16="http://schemas.microsoft.com/office/drawing/2014/main" id="{677E86D8-5E19-4BAF-9C45-3288BA750BEA}"/>
               </a:ext>
             </a:extLst>
           </p:cNvPr>
@@ -2922,7 +2922,7 @@
           <p:cNvPr id="2" name="">
             <a:extLst xmlns:a="http://schemas.openxmlformats.org/drawingml/2006/main">
               <a:ext uri="{FF2B5EF4-FFF2-40B4-BE49-F238E27FC236}">
-                <a16:creationId xmlns:a16="http://schemas.microsoft.com/office/drawing/2014/main" id="{BAAFAF8E-B2C8-4E29-A06A-03A070B44877}"/>
+                <a16:creationId xmlns:a16="http://schemas.microsoft.com/office/drawing/2014/main" id="{57EE6CDB-A0D5-427E-A830-58357EA607EF}"/>
               </a:ext>
             </a:extLst>
           </p:cNvPr>
@@ -2979,7 +2979,7 @@
           <p:cNvPr id="3" name="">
             <a:extLst xmlns:a="http://schemas.openxmlformats.org/drawingml/2006/main">
               <a:ext uri="{FF2B5EF4-FFF2-40B4-BE49-F238E27FC236}">
-                <a16:creationId xmlns:a16="http://schemas.microsoft.com/office/drawing/2014/main" id="{F606D034-97BA-4672-938C-D29DC881F4EF}"/>
+                <a16:creationId xmlns:a16="http://schemas.microsoft.com/office/drawing/2014/main" id="{51501353-3C36-4559-BC93-2681C5D45CD3}"/>
               </a:ext>
             </a:extLst>
           </p:cNvPr>
@@ -3036,7 +3036,7 @@
           <p:cNvPr id="4" name="">
             <a:extLst xmlns:a="http://schemas.openxmlformats.org/drawingml/2006/main">
               <a:ext uri="{FF2B5EF4-FFF2-40B4-BE49-F238E27FC236}">
-                <a16:creationId xmlns:a16="http://schemas.microsoft.com/office/drawing/2014/main" id="{93FC0BB7-BA77-47E7-8980-0057F27A14B1}"/>
+                <a16:creationId xmlns:a16="http://schemas.microsoft.com/office/drawing/2014/main" id="{3E941D2A-34A5-45BF-9988-BC9FE662C386}"/>
               </a:ext>
             </a:extLst>
           </p:cNvPr>
@@ -3083,7 +3083,7 @@
                 <a:ea typeface="Arial"/>
                 <a:cs typeface="Arial"/>
               </a:rPr>
-              <a:t>Acceptance scenario · latest rehearsal incomplete</a:t>
+              <a:t>Opening received · shop flow incomplete</a:t>
             </a:r>
           </a:p>
         </p:txBody>
@@ -3093,7 +3093,7 @@
           <p:cNvPr id="5" name="">
             <a:extLst xmlns:a="http://schemas.openxmlformats.org/drawingml/2006/main">
               <a:ext uri="{FF2B5EF4-FFF2-40B4-BE49-F238E27FC236}">
-                <a16:creationId xmlns:a16="http://schemas.microsoft.com/office/drawing/2014/main" id="{C7AB5733-4B40-497C-8893-2A1076AC056B}"/>
+                <a16:creationId xmlns:a16="http://schemas.microsoft.com/office/drawing/2014/main" id="{A5F49E45-9260-4624-A32B-1E58F4E42BD7}"/>
               </a:ext>
             </a:extLst>
           </p:cNvPr>
@@ -3150,7 +3150,7 @@
           <p:cNvPr id="6" name="">
             <a:extLst xmlns:a="http://schemas.openxmlformats.org/drawingml/2006/main">
               <a:ext uri="{FF2B5EF4-FFF2-40B4-BE49-F238E27FC236}">
-                <a16:creationId xmlns:a16="http://schemas.microsoft.com/office/drawing/2014/main" id="{E89161F1-BF98-41F9-A41B-B07E6D3FA369}"/>
+                <a16:creationId xmlns:a16="http://schemas.microsoft.com/office/drawing/2014/main" id="{DD3881BA-2A47-47D1-B375-D5F512F76BED}"/>
               </a:ext>
             </a:extLst>
           </p:cNvPr>
@@ -3162,42 +3162,65 @@
         <p:spPr>
           <a:xfrm xmlns:a="http://schemas.openxmlformats.org/drawingml/2006/main">
             <a:off x="704850" y="2638425"/>
-            <a:ext cx="5448300" cy="552450"/>
-          </a:xfrm>
-          <a:prstGeom xmlns:a="http://schemas.openxmlformats.org/drawingml/2006/main" prst="rect">
-            <a:avLst/>
-          </a:prstGeom>
-          <a:noFill xmlns:a="http://schemas.openxmlformats.org/drawingml/2006/main"/>
-          <a:ln xmlns:a="http://schemas.openxmlformats.org/drawingml/2006/main" w="0">
-            <a:noFill/>
-          </a:ln>
-        </p:spPr>
-        <p:txBody>
-          <a:bodyPr xmlns:a="http://schemas.openxmlformats.org/drawingml/2006/main" anchor="t">
-            <a:noAutofit/>
-          </a:bodyPr>
-          <a:lstStyle xmlns:a="http://schemas.openxmlformats.org/drawingml/2006/main"/>
-          <a:p xmlns:a="http://schemas.openxmlformats.org/drawingml/2006/main">
-            <a:pPr>
-              <a:defRPr sz="2550" b="1">
-                <a:solidFill>
-                  <a:srgbClr val="1B5147"/>
-                </a:solidFill>
-                <a:latin typeface="Arial"/>
-                <a:ea typeface="Arial"/>
-                <a:cs typeface="Arial"/>
-              </a:defRPr>
-            </a:pPr>
-            <a:r>
-              <a:rPr sz="2550" b="1">
-                <a:solidFill>
-                  <a:srgbClr val="1B5147"/>
-                </a:solidFill>
-                <a:latin typeface="Arial"/>
-                <a:ea typeface="Arial"/>
-                <a:cs typeface="Arial"/>
-              </a:rPr>
-              <a:t>“I want to go to a hospital.”</a:t>
+            <a:ext cx="5448300" cy="895350"/>
+          </a:xfrm>
+          <a:prstGeom xmlns:a="http://schemas.openxmlformats.org/drawingml/2006/main" prst="rect">
+            <a:avLst/>
+          </a:prstGeom>
+          <a:noFill xmlns:a="http://schemas.openxmlformats.org/drawingml/2006/main"/>
+          <a:ln xmlns:a="http://schemas.openxmlformats.org/drawingml/2006/main" w="0">
+            <a:noFill/>
+          </a:ln>
+        </p:spPr>
+        <p:txBody>
+          <a:bodyPr xmlns:a="http://schemas.openxmlformats.org/drawingml/2006/main" anchor="t">
+            <a:noAutofit/>
+          </a:bodyPr>
+          <a:lstStyle xmlns:a="http://schemas.openxmlformats.org/drawingml/2006/main"/>
+          <a:p xmlns:a="http://schemas.openxmlformats.org/drawingml/2006/main">
+            <a:pPr>
+              <a:defRPr sz="2400" b="1">
+                <a:solidFill>
+                  <a:srgbClr val="1B5147"/>
+                </a:solidFill>
+                <a:latin typeface="Arial"/>
+                <a:ea typeface="Arial"/>
+                <a:cs typeface="Arial"/>
+              </a:defRPr>
+            </a:pPr>
+            <a:r>
+              <a:rPr sz="2400" b="1">
+                <a:solidFill>
+                  <a:srgbClr val="1B5147"/>
+                </a:solidFill>
+                <a:latin typeface="Arial"/>
+                <a:ea typeface="Arial"/>
+                <a:cs typeface="Arial"/>
+              </a:rPr>
+              <a:t>“Can you help me check whether</a:t>
+            </a:r>
+          </a:p>
+          <a:p xmlns:a="http://schemas.openxmlformats.org/drawingml/2006/main">
+            <a:pPr>
+              <a:defRPr sz="2400" b="1">
+                <a:solidFill>
+                  <a:srgbClr val="1B5147"/>
+                </a:solidFill>
+                <a:latin typeface="Arial"/>
+                <a:ea typeface="Arial"/>
+                <a:cs typeface="Arial"/>
+              </a:defRPr>
+            </a:pPr>
+            <a:r>
+              <a:rPr sz="2400" b="1">
+                <a:solidFill>
+                  <a:srgbClr val="1B5147"/>
+                </a:solidFill>
+                <a:latin typeface="Arial"/>
+                <a:ea typeface="Arial"/>
+                <a:cs typeface="Arial"/>
+              </a:rPr>
+              <a:t>a shop has an item in stock?”</a:t>
             </a:r>
           </a:p>
         </p:txBody>
@@ -3207,19 +3230,19 @@
           <p:cNvPr id="7" name="">
             <a:extLst xmlns:a="http://schemas.openxmlformats.org/drawingml/2006/main">
               <a:ext uri="{FF2B5EF4-FFF2-40B4-BE49-F238E27FC236}">
-                <a16:creationId xmlns:a16="http://schemas.microsoft.com/office/drawing/2014/main" id="{FE968D87-F04C-43E2-912E-3E519B7055C7}"/>
-              </a:ext>
-            </a:extLst>
-          </p:cNvPr>
-          <p:cNvSpPr>
-            <a:spLocks xmlns:a="http://schemas.openxmlformats.org/drawingml/2006/main" noGrp="1"/>
-          </p:cNvSpPr>
-          <p:nvPr/>
-        </p:nvSpPr>
-        <p:spPr>
-          <a:xfrm xmlns:a="http://schemas.openxmlformats.org/drawingml/2006/main">
-            <a:off x="704850" y="3467100"/>
-            <a:ext cx="5381625" cy="1390650"/>
+                <a16:creationId xmlns:a16="http://schemas.microsoft.com/office/drawing/2014/main" id="{947714B9-FC64-4783-AD76-608DCAB86045}"/>
+              </a:ext>
+            </a:extLst>
+          </p:cNvPr>
+          <p:cNvSpPr>
+            <a:spLocks xmlns:a="http://schemas.openxmlformats.org/drawingml/2006/main" noGrp="1"/>
+          </p:cNvSpPr>
+          <p:nvPr/>
+        </p:nvSpPr>
+        <p:spPr>
+          <a:xfrm xmlns:a="http://schemas.openxmlformats.org/drawingml/2006/main">
+            <a:off x="704850" y="3648075"/>
+            <a:ext cx="5381625" cy="1209675"/>
           </a:xfrm>
           <a:prstGeom xmlns:a="http://schemas.openxmlformats.org/drawingml/2006/main" prst="rect">
             <a:avLst/>
@@ -3310,7 +3333,7 @@
           <p:cNvPr id="8" name="">
             <a:extLst xmlns:a="http://schemas.openxmlformats.org/drawingml/2006/main">
               <a:ext uri="{FF2B5EF4-FFF2-40B4-BE49-F238E27FC236}">
-                <a16:creationId xmlns:a16="http://schemas.microsoft.com/office/drawing/2014/main" id="{FF478F56-E70A-4CD6-B219-EE30D8039D14}"/>
+                <a16:creationId xmlns:a16="http://schemas.microsoft.com/office/drawing/2014/main" id="{4A3E6363-7EC1-4111-AD61-5A96DEB6646F}"/>
               </a:ext>
             </a:extLst>
           </p:cNvPr>
@@ -3367,7 +3390,7 @@
           <p:cNvPr id="9" name="">
             <a:extLst xmlns:a="http://schemas.openxmlformats.org/drawingml/2006/main">
               <a:ext uri="{FF2B5EF4-FFF2-40B4-BE49-F238E27FC236}">
-                <a16:creationId xmlns:a16="http://schemas.microsoft.com/office/drawing/2014/main" id="{D40353E8-76F9-46E8-9A4C-41F3B5C955B5}"/>
+                <a16:creationId xmlns:a16="http://schemas.microsoft.com/office/drawing/2014/main" id="{305BB538-4269-43B4-AE24-038E1085D4B9}"/>
               </a:ext>
             </a:extLst>
           </p:cNvPr>
@@ -3447,7 +3470,7 @@
           <p:cNvPr id="10" name="">
             <a:extLst xmlns:a="http://schemas.openxmlformats.org/drawingml/2006/main">
               <a:ext uri="{FF2B5EF4-FFF2-40B4-BE49-F238E27FC236}">
-                <a16:creationId xmlns:a16="http://schemas.microsoft.com/office/drawing/2014/main" id="{6CB250AB-1F60-4034-A572-9AD644AC2213}"/>
+                <a16:creationId xmlns:a16="http://schemas.microsoft.com/office/drawing/2014/main" id="{B991AD14-6B2B-4BC5-B2A7-4131F6CD7649}"/>
               </a:ext>
             </a:extLst>
           </p:cNvPr>
@@ -3550,7 +3573,7 @@
           <p:cNvPr id="11" name="">
             <a:extLst xmlns:a="http://schemas.openxmlformats.org/drawingml/2006/main">
               <a:ext uri="{FF2B5EF4-FFF2-40B4-BE49-F238E27FC236}">
-                <a16:creationId xmlns:a16="http://schemas.microsoft.com/office/drawing/2014/main" id="{A3465E71-C355-4637-8F5A-5AC9FB7493F5}"/>
+                <a16:creationId xmlns:a16="http://schemas.microsoft.com/office/drawing/2014/main" id="{5F7F2D01-1031-49C0-A2A0-18C6052CE18C}"/>
               </a:ext>
             </a:extLst>
           </p:cNvPr>
@@ -3597,7 +3620,7 @@
                 <a:ea typeface="Arial"/>
                 <a:cs typeface="Arial"/>
               </a:rPr>
-              <a:t>The teammate asks a detail the interview has not covered.</a:t>
+              <a:t>Navy is known. Whether black is acceptable is still unknown.</a:t>
             </a:r>
           </a:p>
           <a:p xmlns:a="http://schemas.openxmlformats.org/drawingml/2006/main">
@@ -3620,7 +3643,7 @@
                 <a:ea typeface="Arial"/>
                 <a:cs typeface="Arial"/>
               </a:rPr>
-              <a:t>The AI asks the customer, waits, and relays the answer in Korean.</a:t>
+              <a:t>The planned relay asks the customer, then returns the answer in Korean.</a:t>
             </a:r>
           </a:p>
         </p:txBody>
@@ -3630,7 +3653,7 @@
           <p:cNvPr id="12" name="">
             <a:extLst xmlns:a="http://schemas.openxmlformats.org/drawingml/2006/main">
               <a:ext uri="{FF2B5EF4-FFF2-40B4-BE49-F238E27FC236}">
-                <a16:creationId xmlns:a16="http://schemas.microsoft.com/office/drawing/2014/main" id="{7BA9D32D-4DDB-4EFF-93D8-24020444ECFD}"/>
+                <a16:creationId xmlns:a16="http://schemas.microsoft.com/office/drawing/2014/main" id="{1D1EDDF9-3079-4EE8-97A9-6238C1C96FC1}"/>
               </a:ext>
             </a:extLst>
           </p:cNvPr>
@@ -3685,7 +3708,7 @@
     </p:spTree>
     <p:extLst>
       <p:ext uri="{BB962C8B-B14F-4D97-AF65-F5344CB8AC3E}">
-        <p14:creationId xmlns:p14="http://schemas.microsoft.com/office/powerpoint/2010/main" val="105122681"/>
+        <p14:creationId xmlns:p14="http://schemas.microsoft.com/office/powerpoint/2010/main" val="2136494099"/>
       </p:ext>
     </p:extLst>
   </p:cSld>
@@ -3716,7 +3739,7 @@
           <p:cNvPr id="11" name="">
             <a:extLst xmlns:a="http://schemas.openxmlformats.org/drawingml/2006/main">
               <a:ext uri="{FF2B5EF4-FFF2-40B4-BE49-F238E27FC236}">
-                <a16:creationId xmlns:a16="http://schemas.microsoft.com/office/drawing/2014/main" id="{83D6E00D-31BF-479D-B56F-81AB9A9CA8A0}"/>
+                <a16:creationId xmlns:a16="http://schemas.microsoft.com/office/drawing/2014/main" id="{8AA3B214-2A8B-4395-AF53-9C5E87C1B58F}"/>
               </a:ext>
             </a:extLst>
           </p:cNvPr>
@@ -3773,7 +3796,7 @@
           <p:cNvPr id="2" name="">
             <a:extLst xmlns:a="http://schemas.openxmlformats.org/drawingml/2006/main">
               <a:ext uri="{FF2B5EF4-FFF2-40B4-BE49-F238E27FC236}">
-                <a16:creationId xmlns:a16="http://schemas.microsoft.com/office/drawing/2014/main" id="{1E899E29-4481-44A5-86D2-12B5647BFB5C}"/>
+                <a16:creationId xmlns:a16="http://schemas.microsoft.com/office/drawing/2014/main" id="{97F54962-0C4B-4509-841D-A0F521A90CA3}"/>
               </a:ext>
             </a:extLst>
           </p:cNvPr>
@@ -3830,7 +3853,7 @@
           <p:cNvPr id="3" name="">
             <a:extLst xmlns:a="http://schemas.openxmlformats.org/drawingml/2006/main">
               <a:ext uri="{FF2B5EF4-FFF2-40B4-BE49-F238E27FC236}">
-                <a16:creationId xmlns:a16="http://schemas.microsoft.com/office/drawing/2014/main" id="{D164E1C7-3165-4E67-A71E-5C3E8DE1E4BE}"/>
+                <a16:creationId xmlns:a16="http://schemas.microsoft.com/office/drawing/2014/main" id="{2B782932-EF48-4387-83E9-9C49AC8E8A4D}"/>
               </a:ext>
             </a:extLst>
           </p:cNvPr>
@@ -3887,7 +3910,7 @@
           <p:cNvPr id="4" name="">
             <a:extLst xmlns:a="http://schemas.openxmlformats.org/drawingml/2006/main">
               <a:ext uri="{FF2B5EF4-FFF2-40B4-BE49-F238E27FC236}">
-                <a16:creationId xmlns:a16="http://schemas.microsoft.com/office/drawing/2014/main" id="{A6215D9B-796F-4CF0-BD27-A7573280AFEC}"/>
+                <a16:creationId xmlns:a16="http://schemas.microsoft.com/office/drawing/2014/main" id="{45CA7C13-B4B1-475B-ABFB-BEF74BCDDC77}"/>
               </a:ext>
             </a:extLst>
           </p:cNvPr>
@@ -3944,7 +3967,7 @@
           <p:cNvPr id="5" name="">
             <a:extLst xmlns:a="http://schemas.openxmlformats.org/drawingml/2006/main">
               <a:ext uri="{FF2B5EF4-FFF2-40B4-BE49-F238E27FC236}">
-                <a16:creationId xmlns:a16="http://schemas.microsoft.com/office/drawing/2014/main" id="{0BA446E1-B1A0-4A00-A88B-975B23EA2112}"/>
+                <a16:creationId xmlns:a16="http://schemas.microsoft.com/office/drawing/2014/main" id="{05A5CFEA-1AC9-4A76-89A5-19B0916A9C88}"/>
               </a:ext>
             </a:extLst>
           </p:cNvPr>
@@ -3991,7 +4014,7 @@
                 <a:ea typeface="Arial"/>
                 <a:cs typeface="Arial"/>
               </a:rPr>
-              <a:t>57 code + 17 HTTP checks passed. Mocked browser checks:</a:t>
+              <a:t>63 code + 23 HTTP checks passed. Mocked browser checks:</a:t>
             </a:r>
           </a:p>
           <a:p xmlns:a="http://schemas.openxmlformats.org/drawingml/2006/main">
@@ -4014,7 +4037,7 @@
                 <a:ea typeface="Arial"/>
                 <a:cs typeface="Arial"/>
               </a:rPr>
-              <a:t>20 customer + 11 business checks passed.</a:t>
+              <a:t>20 customer + 14 business checks passed.</a:t>
             </a:r>
           </a:p>
         </p:txBody>
@@ -4024,7 +4047,7 @@
           <p:cNvPr id="6" name="">
             <a:extLst xmlns:a="http://schemas.openxmlformats.org/drawingml/2006/main">
               <a:ext uri="{FF2B5EF4-FFF2-40B4-BE49-F238E27FC236}">
-                <a16:creationId xmlns:a16="http://schemas.microsoft.com/office/drawing/2014/main" id="{705983EC-155A-403C-8306-0CDD0D619295}"/>
+                <a16:creationId xmlns:a16="http://schemas.microsoft.com/office/drawing/2014/main" id="{56205C77-B2D6-4B5D-BDC7-15D65177786A}"/>
               </a:ext>
             </a:extLst>
           </p:cNvPr>
@@ -4071,7 +4094,7 @@
                 <a:ea typeface="Arial"/>
                 <a:cs typeface="Arial"/>
               </a:rPr>
-              <a:t>These checks do not establish real speech quality or user value.</a:t>
+              <a:t>HTTP setup plans are synthetic. These checks do not prove speech or value.</a:t>
             </a:r>
           </a:p>
         </p:txBody>
@@ -4081,7 +4104,7 @@
           <p:cNvPr id="7" name="">
             <a:extLst xmlns:a="http://schemas.openxmlformats.org/drawingml/2006/main">
               <a:ext uri="{FF2B5EF4-FFF2-40B4-BE49-F238E27FC236}">
-                <a16:creationId xmlns:a16="http://schemas.microsoft.com/office/drawing/2014/main" id="{E3F62FB0-1F62-4236-A53E-D232CB80A57F}"/>
+                <a16:creationId xmlns:a16="http://schemas.microsoft.com/office/drawing/2014/main" id="{EEAFDB05-4601-40A6-A298-8BD730B4E926}"/>
               </a:ext>
             </a:extLst>
           </p:cNvPr>
@@ -4128,7 +4151,7 @@
                 <a:ea typeface="Arial"/>
                 <a:cs typeface="Arial"/>
               </a:rPr>
-              <a:t>Actual Korean speech: Partial</a:t>
+              <a:t>Latest shop voice attempt: Partial</a:t>
             </a:r>
           </a:p>
         </p:txBody>
@@ -4138,7 +4161,7 @@
           <p:cNvPr id="8" name="">
             <a:extLst xmlns:a="http://schemas.openxmlformats.org/drawingml/2006/main">
               <a:ext uri="{FF2B5EF4-FFF2-40B4-BE49-F238E27FC236}">
-                <a16:creationId xmlns:a16="http://schemas.microsoft.com/office/drawing/2014/main" id="{D1A2F8DF-D7E9-496A-B06C-2D47491E58E6}"/>
+                <a16:creationId xmlns:a16="http://schemas.microsoft.com/office/drawing/2014/main" id="{DCE41109-2354-4547-AD7A-54358F077CBC}"/>
               </a:ext>
             </a:extLst>
           </p:cNvPr>
@@ -4185,7 +4208,7 @@
                 <a:ea typeface="Arial"/>
                 <a:cs typeface="Arial"/>
               </a:rPr>
-              <a:t>Four spoken answers and a Korean readback were captured.</a:t>
+              <a:t>Korean opening received; human audibility not confirmed.</a:t>
             </a:r>
           </a:p>
           <a:p xmlns:a="http://schemas.openxmlformats.org/drawingml/2006/main">
@@ -4208,7 +4231,7 @@
                 <a:ea typeface="Arial"/>
                 <a:cs typeface="Arial"/>
               </a:rPr>
-              <a:t>Confirmation reset the answers; the teammate ended the run.</a:t>
+              <a:t>Stock and price were wrongly inferred; mic stalled, operator ended.</a:t>
             </a:r>
           </a:p>
         </p:txBody>
@@ -4218,7 +4241,7 @@
           <p:cNvPr id="9" name="">
             <a:extLst xmlns:a="http://schemas.openxmlformats.org/drawingml/2006/main">
               <a:ext uri="{FF2B5EF4-FFF2-40B4-BE49-F238E27FC236}">
-                <a16:creationId xmlns:a16="http://schemas.microsoft.com/office/drawing/2014/main" id="{874F917E-662B-48B9-A292-E787698B10F1}"/>
+                <a16:creationId xmlns:a16="http://schemas.microsoft.com/office/drawing/2014/main" id="{FFB03FF8-06E9-40CE-A965-A9C85DE71884}"/>
               </a:ext>
             </a:extLst>
           </p:cNvPr>
@@ -4265,7 +4288,7 @@
                 <a:ea typeface="Arial"/>
                 <a:cs typeface="Arial"/>
               </a:rPr>
-              <a:t>Still unverified</a:t>
+              <a:t>Text replay passed; live repeat pending</a:t>
             </a:r>
           </a:p>
         </p:txBody>
@@ -4275,7 +4298,7 @@
           <p:cNvPr id="10" name="">
             <a:extLst xmlns:a="http://schemas.openxmlformats.org/drawingml/2006/main">
               <a:ext uri="{FF2B5EF4-FFF2-40B4-BE49-F238E27FC236}">
-                <a16:creationId xmlns:a16="http://schemas.microsoft.com/office/drawing/2014/main" id="{6BD96BBF-52BB-4042-9856-527898F42E23}"/>
+                <a16:creationId xmlns:a16="http://schemas.microsoft.com/office/drawing/2014/main" id="{045CC994-B281-4998-B55E-3E0FA52E9847}"/>
               </a:ext>
             </a:extLst>
           </p:cNvPr>
@@ -4322,7 +4345,7 @@
                 <a:ea typeface="Arial"/>
                 <a:cs typeface="Arial"/>
               </a:rPr>
-              <a:t>Live unknown-detail relay and normal completion: Unverified.</a:t>
+              <a:t>Recorded-text advice: 9/9 checks with one real API request.</a:t>
             </a:r>
           </a:p>
           <a:p xmlns:a="http://schemas.openxmlformats.org/drawingml/2006/main">
@@ -4345,7 +4368,7 @@
                 <a:ea typeface="Arial"/>
                 <a:cs typeface="Arial"/>
               </a:rPr>
-              <a:t>Russian/Chinese interviews exercised; fidelity limits remain.</a:t>
+              <a:t>Shop audibility, live relay and normal completion: Unverified.</a:t>
             </a:r>
           </a:p>
         </p:txBody>
@@ -4353,7 +4376,7 @@
     </p:spTree>
     <p:extLst>
       <p:ext uri="{BB962C8B-B14F-4D97-AF65-F5344CB8AC3E}">
-        <p14:creationId xmlns:p14="http://schemas.microsoft.com/office/powerpoint/2010/main" val="1759203769"/>
+        <p14:creationId xmlns:p14="http://schemas.microsoft.com/office/powerpoint/2010/main" val="1538490241"/>
       </p:ext>
     </p:extLst>
   </p:cSld>
@@ -4384,7 +4407,7 @@
           <p:cNvPr id="9" name="">
             <a:extLst xmlns:a="http://schemas.openxmlformats.org/drawingml/2006/main">
               <a:ext uri="{FF2B5EF4-FFF2-40B4-BE49-F238E27FC236}">
-                <a16:creationId xmlns:a16="http://schemas.microsoft.com/office/drawing/2014/main" id="{B672884A-EAA1-479F-A796-D90AFA56487F}"/>
+                <a16:creationId xmlns:a16="http://schemas.microsoft.com/office/drawing/2014/main" id="{693AB2E7-1F08-4C0E-BEA6-177D80B5983C}"/>
               </a:ext>
             </a:extLst>
           </p:cNvPr>
@@ -4441,7 +4464,7 @@
           <p:cNvPr id="2" name="">
             <a:extLst xmlns:a="http://schemas.openxmlformats.org/drawingml/2006/main">
               <a:ext uri="{FF2B5EF4-FFF2-40B4-BE49-F238E27FC236}">
-                <a16:creationId xmlns:a16="http://schemas.microsoft.com/office/drawing/2014/main" id="{B2EBA36D-EEDB-4662-B661-E0C90D5707B7}"/>
+                <a16:creationId xmlns:a16="http://schemas.microsoft.com/office/drawing/2014/main" id="{1C1E8B29-8404-4A3E-94C6-ECC618E7A9BA}"/>
               </a:ext>
             </a:extLst>
           </p:cNvPr>
@@ -4498,7 +4521,7 @@
           <p:cNvPr id="3" name="">
             <a:extLst xmlns:a="http://schemas.openxmlformats.org/drawingml/2006/main">
               <a:ext uri="{FF2B5EF4-FFF2-40B4-BE49-F238E27FC236}">
-                <a16:creationId xmlns:a16="http://schemas.microsoft.com/office/drawing/2014/main" id="{12F3F7E2-661F-431F-85B9-8825EF61E3B5}"/>
+                <a16:creationId xmlns:a16="http://schemas.microsoft.com/office/drawing/2014/main" id="{3B0E42DF-2E46-415D-BE73-145B06A26744}"/>
               </a:ext>
             </a:extLst>
           </p:cNvPr>
@@ -4555,7 +4578,7 @@
           <p:cNvPr id="4" name="">
             <a:extLst xmlns:a="http://schemas.openxmlformats.org/drawingml/2006/main">
               <a:ext uri="{FF2B5EF4-FFF2-40B4-BE49-F238E27FC236}">
-                <a16:creationId xmlns:a16="http://schemas.microsoft.com/office/drawing/2014/main" id="{A78346E7-714F-4418-B730-5577D7CA7B81}"/>
+                <a16:creationId xmlns:a16="http://schemas.microsoft.com/office/drawing/2014/main" id="{C95E0430-544F-4583-A262-4384AC1B7B04}"/>
               </a:ext>
             </a:extLst>
           </p:cNvPr>
@@ -4635,7 +4658,7 @@
           <p:cNvPr id="5" name="">
             <a:extLst xmlns:a="http://schemas.openxmlformats.org/drawingml/2006/main">
               <a:ext uri="{FF2B5EF4-FFF2-40B4-BE49-F238E27FC236}">
-                <a16:creationId xmlns:a16="http://schemas.microsoft.com/office/drawing/2014/main" id="{5FBEC121-3FDC-4DCE-9CDE-6449E54DBF35}"/>
+                <a16:creationId xmlns:a16="http://schemas.microsoft.com/office/drawing/2014/main" id="{B7997E78-C16E-4CD9-B8C0-0FF34109C488}"/>
               </a:ext>
             </a:extLst>
           </p:cNvPr>
@@ -4692,7 +4715,7 @@
           <p:cNvPr id="6" name="">
             <a:extLst xmlns:a="http://schemas.openxmlformats.org/drawingml/2006/main">
               <a:ext uri="{FF2B5EF4-FFF2-40B4-BE49-F238E27FC236}">
-                <a16:creationId xmlns:a16="http://schemas.microsoft.com/office/drawing/2014/main" id="{8D93B7C2-8759-4E07-8E6F-D3758A8E064B}"/>
+                <a16:creationId xmlns:a16="http://schemas.microsoft.com/office/drawing/2014/main" id="{9B621BE3-BBEB-48E6-A627-5F4AD4FBAFA6}"/>
               </a:ext>
             </a:extLst>
           </p:cNvPr>
@@ -4749,7 +4772,7 @@
           <p:cNvPr id="7" name="">
             <a:extLst xmlns:a="http://schemas.openxmlformats.org/drawingml/2006/main">
               <a:ext uri="{FF2B5EF4-FFF2-40B4-BE49-F238E27FC236}">
-                <a16:creationId xmlns:a16="http://schemas.microsoft.com/office/drawing/2014/main" id="{9E9A3261-8244-4344-8212-8F812E60EFC4}"/>
+                <a16:creationId xmlns:a16="http://schemas.microsoft.com/office/drawing/2014/main" id="{4A4AE514-DD79-4160-A67A-9B82FACC9B6B}"/>
               </a:ext>
             </a:extLst>
           </p:cNvPr>
@@ -4806,7 +4829,7 @@
           <p:cNvPr id="8" name="">
             <a:extLst xmlns:a="http://schemas.openxmlformats.org/drawingml/2006/main">
               <a:ext uri="{FF2B5EF4-FFF2-40B4-BE49-F238E27FC236}">
-                <a16:creationId xmlns:a16="http://schemas.microsoft.com/office/drawing/2014/main" id="{6A99D211-A7C3-40C3-8833-FDD61A0CC51A}"/>
+                <a16:creationId xmlns:a16="http://schemas.microsoft.com/office/drawing/2014/main" id="{37E04880-F93C-432C-BDB6-CF8A56E0B8A0}"/>
               </a:ext>
             </a:extLst>
           </p:cNvPr>
@@ -4884,7 +4907,7 @@
     </p:spTree>
     <p:extLst>
       <p:ext uri="{BB962C8B-B14F-4D97-AF65-F5344CB8AC3E}">
-        <p14:creationId xmlns:p14="http://schemas.microsoft.com/office/powerpoint/2010/main" val="1328362818"/>
+        <p14:creationId xmlns:p14="http://schemas.microsoft.com/office/powerpoint/2010/main" val="1294469842"/>
       </p:ext>
     </p:extLst>
   </p:cSld>

</xml_diff>

<commit_message>
Record successful live shop flow and refresh submission artifacts
</commit_message>
<xml_diff>
--- a/submission/v2/slides.pptx
+++ b/submission/v2/slides.pptx
@@ -2,17 +2,17 @@
 <file path=ppt/presentation.xml><?xml version="1.0" encoding="utf-8"?>
 <p:presentation xmlns:p="http://schemas.openxmlformats.org/presentationml/2006/main">
   <p:sldMasterIdLst>
-    <p:sldMasterId xmlns:r="http://schemas.openxmlformats.org/officeDocument/2006/relationships" id="2147483648" r:id="R8d4f54d3bd1a429c"/>
+    <p:sldMasterId xmlns:r="http://schemas.openxmlformats.org/officeDocument/2006/relationships" id="2147483648" r:id="R5e90e6947e2c4332"/>
   </p:sldMasterIdLst>
   <p:notesMasterIdLst>
-    <p:notesMasterId xmlns:r="http://schemas.openxmlformats.org/officeDocument/2006/relationships" r:id="R24760e2fa7f94644"/>
+    <p:notesMasterId xmlns:r="http://schemas.openxmlformats.org/officeDocument/2006/relationships" r:id="R73ae07bc843d40e7"/>
   </p:notesMasterIdLst>
   <p:sldIdLst>
-    <p:sldId xmlns:r="http://schemas.openxmlformats.org/officeDocument/2006/relationships" id="256" r:id="R815042900d0640e7"/>
-    <p:sldId xmlns:r="http://schemas.openxmlformats.org/officeDocument/2006/relationships" id="257" r:id="Rfbf422c315bb456c"/>
-    <p:sldId xmlns:r="http://schemas.openxmlformats.org/officeDocument/2006/relationships" id="258" r:id="Rcc4873ec3d894ce3"/>
-    <p:sldId xmlns:r="http://schemas.openxmlformats.org/officeDocument/2006/relationships" id="259" r:id="Rf433d52a9ee74507"/>
-    <p:sldId xmlns:r="http://schemas.openxmlformats.org/officeDocument/2006/relationships" id="260" r:id="R47995446ee104053"/>
+    <p:sldId xmlns:r="http://schemas.openxmlformats.org/officeDocument/2006/relationships" id="256" r:id="Rff9594bb891c497f"/>
+    <p:sldId xmlns:r="http://schemas.openxmlformats.org/officeDocument/2006/relationships" id="257" r:id="R9abfaa57398340e5"/>
+    <p:sldId xmlns:r="http://schemas.openxmlformats.org/officeDocument/2006/relationships" id="258" r:id="R00f9086ecd9c4c75"/>
+    <p:sldId xmlns:r="http://schemas.openxmlformats.org/officeDocument/2006/relationships" id="259" r:id="Rac9e705689704913"/>
+    <p:sldId xmlns:r="http://schemas.openxmlformats.org/officeDocument/2006/relationships" id="260" r:id="R48383979b3a14e7c"/>
   </p:sldIdLst>
   <p:sldSz cx="12192000" cy="6858000"/>
   <p:notesSz cx="6858000" cy="9144000"/>
@@ -601,7 +601,7 @@
           </a:p>
           <a:p xmlns:a="http://schemas.openxmlformats.org/drawingml/2006/main">
             <a:r>
-              <a:t>0:55–2:00. The current shop example requests a navy waterproof daypack of about 20 litres, any brand, in Mapo for evening pickup. A bounded real API interview prepared stock, price and closing/pickup questions; six provider responses, two customer turns. The price question says available before stock is confirmed, a disclosed wording limitation. No stock, price or hours are established. The actual shop room accepted at 15:12:16 KST and received the full Korean opening and stock question. The operator ended at 15:15:45 after unsupported stock/price classification and a microphone stall. Human audibility is not confirmed. Source: artifacts/v2/live-shop-first-attempt.json. Ask conditionally whether black would be acceptable; never assume the preference. Source: artifacts/v2/live-shop-plan-check.json; docs/v2-shop-demo.md. Open a separate business tab on the same laptop. It must remain inactive before customer authorization. Accept only when incoming. Use fictional customer details and business answers. Choose an unknown customer detail based on the actual interview, rather than assuming prior-visit status is unknown. The third actual rehearsal captured four business answers and a readback, but confirmation reset the answers and the teammate disconnected. Unknown-detail relay and a normal completed call remain unverified. Demonstrate these steps only if a new real run actually reaches them.</a:t>
+              <a:t>0:55–2:00. The fifth PR rehearsal completed at 16:04 KST on this laptop. The customer requested navy waterproof daypack stock, price and latest evening pickup. After authorization and acceptance, the Korean-speaking teammate said navy was unavailable and black available without explicitly asking a question. YOKOBU proactively asked the customer whether black was acceptable. The human customer replied yes; YOKOBU returned that choice in Korean and updated the current questions. The earlier stock answer was retained. The teammate gave 10,000 won and pickup until 7 PM. A full readback was confirmed and the call completed normally. One price utterance was transcribed only as an incomplete fragment and required clarification. The user confirmed the Korean opening, return, goodbye and microphone shutdown. Source: artifacts/v2/pr1-live-shop-fifth-completed.json and docs/v2-pr1-review.md. All information is fictional; no order or reservation occurred.</a:t>
             </a:r>
           </a:p>
         </p:txBody>
@@ -676,7 +676,7 @@
           </a:p>
           <a:p xmlns:a="http://schemas.openxmlformats.org/drawingml/2006/main">
             <a:r>
-              <a:t>2:00–2:30. The current code checkpoint has 63 local tests (31 state, 17 guard, 15 legacy), 23 actual local HTTP checks with synthetic setup plans and upstream network blocked, 20 mocked customer browser checks, and 14 mocked business browser checks. These are different evidence classes. The third real laptop microphone run captured four actual Korean business answers and an assistant readback, including qualified cost uncertainty. Business confirmation incorrectly reset the resolved state; the human disconnected. Korean audibility was human-confirmed in the first attempt only. Unknown-detail relay was not exercised in the third attempt. Later readback and startup fixes require another live rehearsal. Startup now waits for session.created, a remote track and connection registration, sends one tool-free opening, and pauses the microphone through completed playback and playback permission; missing opening audio fails after 12 seconds. The new shop opening audio started at 15:12:19.502 and its full greeting/stock-question transcript was captured, but human audibility is not confirmed. Only a business greeting and apology were transcribed. The review incorrectly classified those as negative stock and unavailable price; that unsupported state also entered the summary. Consecutive responses left the microphone paused; the operator ended at 15:15:45. Repairs are pending, and no live relay or normal completion is claimed. Source: artifacts/v2/live-shop-first-attempt.json. A separate recorded-text summary regression passed 9/9 using one real structured recommendation request. The AI chose an allowed action and existing answer references; rendering preserved the original interrupted outcome and qualified price, without new microphone or audio evidence. Source: artifacts/v2/recorded-third-typed-summary-check.json. Real Russian and Chinese interviews were exercised, but Korean question fidelity and unsupported first-visit wording remain limited. Sources: artifacts/v2/live-native-rehearsal-third-attempt.json; artifacts/v2/live-native-third-attempt-audit.json; artifacts/v2/customer-ui-check.json; docs/v2-verification.md. These local evidence files are not raw material for the official upload.</a:t>
+              <a:t>2:00–2:30. Codex used actual failed rehearsals to diagnose ignored business questions, repeated readbacks, unavailable-stock inferences and unchanged question targets after a customer decision. It fixed saved transcript identity at the HTTP boundary, added detection of questions and offered alternatives, preserved supported answers, and refined current targets after real customer replies. The fifth live run completed the core flow. Earlier failures remain preserved. Its source was committed as 8ce4526; teammate concise-result and shutdown changes through 92cedd6 were then integrated and regression-tested. Combined checks: 67 unit, 30 localhost HTTP with mocked AI, 20 customer UI, 19 business UI, 32 design and eight extracted-package checks; build passed. These tests do not establish another live run or broad reliability. English, Russian and Chinese interfaces are covered; real multilingual model fidelity has recorded limits. Target-user value and physical two-phone connectivity remain unverified. Sources: docs/v2-pr1-review.md and artifacts/v2/pr1-live-shop-fifth-completed.json.</a:t>
             </a:r>
           </a:p>
         </p:txBody>
@@ -819,7 +819,7 @@
   </p:cSld>
   <p:clrMap bg1="lt1" tx1="dk1" bg2="lt2" tx2="dk2" accent1="accent1" accent2="accent2" accent3="accent3" accent4="accent4" accent5="accent5" accent6="accent6" hlink="hlink" folHlink="folHlink"/>
   <p:sldLayoutIdLst>
-    <p:sldLayoutId xmlns:r="http://schemas.openxmlformats.org/officeDocument/2006/relationships" id="2147483649" r:id="R0bf819929ebf4c8a"/>
+    <p:sldLayoutId xmlns:r="http://schemas.openxmlformats.org/officeDocument/2006/relationships" id="2147483649" r:id="Rdf675013b3164657"/>
   </p:sldLayoutIdLst>
   <p:txStyles>
     <p:titleStyle>
@@ -1370,7 +1370,7 @@
           <p:cNvPr id="7" name="">
             <a:extLst xmlns:a="http://schemas.openxmlformats.org/drawingml/2006/main">
               <a:ext uri="{FF2B5EF4-FFF2-40B4-BE49-F238E27FC236}">
-                <a16:creationId xmlns:a16="http://schemas.microsoft.com/office/drawing/2014/main" id="{B874A44B-6DF7-421C-B82A-AC85DE8549CE}"/>
+                <a16:creationId xmlns:a16="http://schemas.microsoft.com/office/drawing/2014/main" id="{72AE9CEB-BB02-4740-BD4C-536FF1F81FF6}"/>
               </a:ext>
             </a:extLst>
           </p:cNvPr>
@@ -1427,7 +1427,7 @@
           <p:cNvPr id="2" name="">
             <a:extLst xmlns:a="http://schemas.openxmlformats.org/drawingml/2006/main">
               <a:ext uri="{FF2B5EF4-FFF2-40B4-BE49-F238E27FC236}">
-                <a16:creationId xmlns:a16="http://schemas.microsoft.com/office/drawing/2014/main" id="{223343EA-E8FC-4E60-931E-BBF99F3CE7F5}"/>
+                <a16:creationId xmlns:a16="http://schemas.microsoft.com/office/drawing/2014/main" id="{63CED414-6126-4F4B-A4B8-96BF9E196886}"/>
               </a:ext>
             </a:extLst>
           </p:cNvPr>
@@ -1484,7 +1484,7 @@
           <p:cNvPr id="3" name="">
             <a:extLst xmlns:a="http://schemas.openxmlformats.org/drawingml/2006/main">
               <a:ext uri="{FF2B5EF4-FFF2-40B4-BE49-F238E27FC236}">
-                <a16:creationId xmlns:a16="http://schemas.microsoft.com/office/drawing/2014/main" id="{0942959A-0236-49C1-8318-653FF18C98BB}"/>
+                <a16:creationId xmlns:a16="http://schemas.microsoft.com/office/drawing/2014/main" id="{6121110D-7AC8-4F45-A5A0-2FC67A6DD27B}"/>
               </a:ext>
             </a:extLst>
           </p:cNvPr>
@@ -1541,7 +1541,7 @@
           <p:cNvPr id="4" name="">
             <a:extLst xmlns:a="http://schemas.openxmlformats.org/drawingml/2006/main">
               <a:ext uri="{FF2B5EF4-FFF2-40B4-BE49-F238E27FC236}">
-                <a16:creationId xmlns:a16="http://schemas.microsoft.com/office/drawing/2014/main" id="{F50FF05C-4142-4673-A4A1-21B418DD852A}"/>
+                <a16:creationId xmlns:a16="http://schemas.microsoft.com/office/drawing/2014/main" id="{5E749132-8BAB-43AF-9BC5-C339A19B8E16}"/>
               </a:ext>
             </a:extLst>
           </p:cNvPr>
@@ -1621,7 +1621,7 @@
           <p:cNvPr id="5" name="">
             <a:extLst xmlns:a="http://schemas.openxmlformats.org/drawingml/2006/main">
               <a:ext uri="{FF2B5EF4-FFF2-40B4-BE49-F238E27FC236}">
-                <a16:creationId xmlns:a16="http://schemas.microsoft.com/office/drawing/2014/main" id="{A080D3EF-1AAB-4B39-B440-0758D5BE1BD5}"/>
+                <a16:creationId xmlns:a16="http://schemas.microsoft.com/office/drawing/2014/main" id="{F8349D15-83D4-44F3-851A-CE5D4ABB3978}"/>
               </a:ext>
             </a:extLst>
           </p:cNvPr>
@@ -1701,7 +1701,7 @@
           <p:cNvPr id="6" name="">
             <a:extLst xmlns:a="http://schemas.openxmlformats.org/drawingml/2006/main">
               <a:ext uri="{FF2B5EF4-FFF2-40B4-BE49-F238E27FC236}">
-                <a16:creationId xmlns:a16="http://schemas.microsoft.com/office/drawing/2014/main" id="{094F947F-A174-4275-B395-DF12208C775D}"/>
+                <a16:creationId xmlns:a16="http://schemas.microsoft.com/office/drawing/2014/main" id="{C8F6654F-E939-4A0B-9FA8-267E12C419FF}"/>
               </a:ext>
             </a:extLst>
           </p:cNvPr>
@@ -1779,7 +1779,7 @@
     </p:spTree>
     <p:extLst>
       <p:ext uri="{BB962C8B-B14F-4D97-AF65-F5344CB8AC3E}">
-        <p14:creationId xmlns:p14="http://schemas.microsoft.com/office/powerpoint/2010/main" val="278343163"/>
+        <p14:creationId xmlns:p14="http://schemas.microsoft.com/office/powerpoint/2010/main" val="2140048813"/>
       </p:ext>
     </p:extLst>
   </p:cSld>
@@ -1810,7 +1810,7 @@
           <p:cNvPr id="19" name="">
             <a:extLst xmlns:a="http://schemas.openxmlformats.org/drawingml/2006/main">
               <a:ext uri="{FF2B5EF4-FFF2-40B4-BE49-F238E27FC236}">
-                <a16:creationId xmlns:a16="http://schemas.microsoft.com/office/drawing/2014/main" id="{85798F62-BC4A-4D43-9854-25D04D0C2BBC}"/>
+                <a16:creationId xmlns:a16="http://schemas.microsoft.com/office/drawing/2014/main" id="{682F5DC6-DEB7-4E8E-A9DC-1D3F48FA7222}"/>
               </a:ext>
             </a:extLst>
           </p:cNvPr>
@@ -1867,7 +1867,7 @@
           <p:cNvPr id="2" name="">
             <a:extLst xmlns:a="http://schemas.openxmlformats.org/drawingml/2006/main">
               <a:ext uri="{FF2B5EF4-FFF2-40B4-BE49-F238E27FC236}">
-                <a16:creationId xmlns:a16="http://schemas.microsoft.com/office/drawing/2014/main" id="{19E2B18B-A536-4C28-9812-8E2B21320DA2}"/>
+                <a16:creationId xmlns:a16="http://schemas.microsoft.com/office/drawing/2014/main" id="{485047D5-5929-45B5-9105-4D3657D1CBAC}"/>
               </a:ext>
             </a:extLst>
           </p:cNvPr>
@@ -1924,7 +1924,7 @@
           <p:cNvPr id="3" name="">
             <a:extLst xmlns:a="http://schemas.openxmlformats.org/drawingml/2006/main">
               <a:ext uri="{FF2B5EF4-FFF2-40B4-BE49-F238E27FC236}">
-                <a16:creationId xmlns:a16="http://schemas.microsoft.com/office/drawing/2014/main" id="{92E82C12-4129-4431-A9E8-C738F5A72C1D}"/>
+                <a16:creationId xmlns:a16="http://schemas.microsoft.com/office/drawing/2014/main" id="{DAEF8C0B-C7B2-4761-8968-AECC7F1DCB19}"/>
               </a:ext>
             </a:extLst>
           </p:cNvPr>
@@ -1981,7 +1981,7 @@
           <p:cNvPr id="4" name="">
             <a:extLst xmlns:a="http://schemas.openxmlformats.org/drawingml/2006/main">
               <a:ext uri="{FF2B5EF4-FFF2-40B4-BE49-F238E27FC236}">
-                <a16:creationId xmlns:a16="http://schemas.microsoft.com/office/drawing/2014/main" id="{269B045A-979E-4AE6-A0F8-674D21D005DE}"/>
+                <a16:creationId xmlns:a16="http://schemas.microsoft.com/office/drawing/2014/main" id="{B645D108-03C1-4A76-8865-8B497DE66D46}"/>
               </a:ext>
             </a:extLst>
           </p:cNvPr>
@@ -2038,7 +2038,7 @@
           <p:cNvPr id="5" name="">
             <a:extLst xmlns:a="http://schemas.openxmlformats.org/drawingml/2006/main">
               <a:ext uri="{FF2B5EF4-FFF2-40B4-BE49-F238E27FC236}">
-                <a16:creationId xmlns:a16="http://schemas.microsoft.com/office/drawing/2014/main" id="{863763D3-10FE-4D8E-95C5-3FB632B2D60A}"/>
+                <a16:creationId xmlns:a16="http://schemas.microsoft.com/office/drawing/2014/main" id="{0541AEA2-3AA9-4B27-9580-FA8C958187FB}"/>
               </a:ext>
             </a:extLst>
           </p:cNvPr>
@@ -2095,7 +2095,7 @@
           <p:cNvPr id="6" name="">
             <a:extLst xmlns:a="http://schemas.openxmlformats.org/drawingml/2006/main">
               <a:ext uri="{FF2B5EF4-FFF2-40B4-BE49-F238E27FC236}">
-                <a16:creationId xmlns:a16="http://schemas.microsoft.com/office/drawing/2014/main" id="{5B9EE51B-FD72-4F7A-8C21-0833075C421D}"/>
+                <a16:creationId xmlns:a16="http://schemas.microsoft.com/office/drawing/2014/main" id="{1D02CFFD-D834-4C69-9405-FA704B8CA098}"/>
               </a:ext>
             </a:extLst>
           </p:cNvPr>
@@ -2152,7 +2152,7 @@
           <p:cNvPr id="7" name="">
             <a:extLst xmlns:a="http://schemas.openxmlformats.org/drawingml/2006/main">
               <a:ext uri="{FF2B5EF4-FFF2-40B4-BE49-F238E27FC236}">
-                <a16:creationId xmlns:a16="http://schemas.microsoft.com/office/drawing/2014/main" id="{BD059D19-DFFA-4074-90D3-8D276647072A}"/>
+                <a16:creationId xmlns:a16="http://schemas.microsoft.com/office/drawing/2014/main" id="{FEF88540-8EA2-4D51-955D-F3A65CA3B34B}"/>
               </a:ext>
             </a:extLst>
           </p:cNvPr>
@@ -2209,7 +2209,7 @@
           <p:cNvPr id="8" name="">
             <a:extLst xmlns:a="http://schemas.openxmlformats.org/drawingml/2006/main">
               <a:ext uri="{FF2B5EF4-FFF2-40B4-BE49-F238E27FC236}">
-                <a16:creationId xmlns:a16="http://schemas.microsoft.com/office/drawing/2014/main" id="{27A3F425-5704-41FE-822B-1140330EEA9C}"/>
+                <a16:creationId xmlns:a16="http://schemas.microsoft.com/office/drawing/2014/main" id="{F613D396-D208-49A6-9821-CB50293C9109}"/>
               </a:ext>
             </a:extLst>
           </p:cNvPr>
@@ -2266,7 +2266,7 @@
           <p:cNvPr id="9" name="">
             <a:extLst xmlns:a="http://schemas.openxmlformats.org/drawingml/2006/main">
               <a:ext uri="{FF2B5EF4-FFF2-40B4-BE49-F238E27FC236}">
-                <a16:creationId xmlns:a16="http://schemas.microsoft.com/office/drawing/2014/main" id="{B12DF5CC-F5EE-4BEF-9193-6FC83B899188}"/>
+                <a16:creationId xmlns:a16="http://schemas.microsoft.com/office/drawing/2014/main" id="{977528D8-596C-4160-9015-7A6ECB67752D}"/>
               </a:ext>
             </a:extLst>
           </p:cNvPr>
@@ -2323,7 +2323,7 @@
           <p:cNvPr id="10" name="">
             <a:extLst xmlns:a="http://schemas.openxmlformats.org/drawingml/2006/main">
               <a:ext uri="{FF2B5EF4-FFF2-40B4-BE49-F238E27FC236}">
-                <a16:creationId xmlns:a16="http://schemas.microsoft.com/office/drawing/2014/main" id="{7D9190CF-68A1-4C8E-8EE1-6D7C9BF2839E}"/>
+                <a16:creationId xmlns:a16="http://schemas.microsoft.com/office/drawing/2014/main" id="{14A1595B-1A1F-4AF1-88C6-238EE1C256A7}"/>
               </a:ext>
             </a:extLst>
           </p:cNvPr>
@@ -2380,7 +2380,7 @@
           <p:cNvPr id="11" name="">
             <a:extLst xmlns:a="http://schemas.openxmlformats.org/drawingml/2006/main">
               <a:ext uri="{FF2B5EF4-FFF2-40B4-BE49-F238E27FC236}">
-                <a16:creationId xmlns:a16="http://schemas.microsoft.com/office/drawing/2014/main" id="{E3639FB3-662E-41E9-9692-57541F7AB435}"/>
+                <a16:creationId xmlns:a16="http://schemas.microsoft.com/office/drawing/2014/main" id="{EC08F996-3147-4F16-95C8-6E0A238C677B}"/>
               </a:ext>
             </a:extLst>
           </p:cNvPr>
@@ -2437,7 +2437,7 @@
           <p:cNvPr id="12" name="">
             <a:extLst xmlns:a="http://schemas.openxmlformats.org/drawingml/2006/main">
               <a:ext uri="{FF2B5EF4-FFF2-40B4-BE49-F238E27FC236}">
-                <a16:creationId xmlns:a16="http://schemas.microsoft.com/office/drawing/2014/main" id="{19372BCF-EE78-4FC3-BB4F-652AABDFD1B5}"/>
+                <a16:creationId xmlns:a16="http://schemas.microsoft.com/office/drawing/2014/main" id="{252C0D75-97FF-463A-A75F-90BAB783FCD1}"/>
               </a:ext>
             </a:extLst>
           </p:cNvPr>
@@ -2494,7 +2494,7 @@
           <p:cNvPr id="13" name="">
             <a:extLst xmlns:a="http://schemas.openxmlformats.org/drawingml/2006/main">
               <a:ext uri="{FF2B5EF4-FFF2-40B4-BE49-F238E27FC236}">
-                <a16:creationId xmlns:a16="http://schemas.microsoft.com/office/drawing/2014/main" id="{CE95F9D7-CCB4-443D-A6A6-6E277CD6CFFF}"/>
+                <a16:creationId xmlns:a16="http://schemas.microsoft.com/office/drawing/2014/main" id="{DB9C8387-F56E-4246-A5C8-75D87EB1950E}"/>
               </a:ext>
             </a:extLst>
           </p:cNvPr>
@@ -2551,7 +2551,7 @@
           <p:cNvPr id="14" name="">
             <a:extLst xmlns:a="http://schemas.openxmlformats.org/drawingml/2006/main">
               <a:ext uri="{FF2B5EF4-FFF2-40B4-BE49-F238E27FC236}">
-                <a16:creationId xmlns:a16="http://schemas.microsoft.com/office/drawing/2014/main" id="{CA9CB2F3-5EFF-4C93-A7C8-9EE63FFE7DF6}"/>
+                <a16:creationId xmlns:a16="http://schemas.microsoft.com/office/drawing/2014/main" id="{207B5FA8-130B-4D74-A0A0-A17EBD1F1BF4}"/>
               </a:ext>
             </a:extLst>
           </p:cNvPr>
@@ -2608,7 +2608,7 @@
           <p:cNvPr id="15" name="">
             <a:extLst xmlns:a="http://schemas.openxmlformats.org/drawingml/2006/main">
               <a:ext uri="{FF2B5EF4-FFF2-40B4-BE49-F238E27FC236}">
-                <a16:creationId xmlns:a16="http://schemas.microsoft.com/office/drawing/2014/main" id="{75D8FFFF-00E3-4ABD-AF4B-0F04963D06BA}"/>
+                <a16:creationId xmlns:a16="http://schemas.microsoft.com/office/drawing/2014/main" id="{00E0FA74-DCC1-46F1-B3B0-97928655C4CC}"/>
               </a:ext>
             </a:extLst>
           </p:cNvPr>
@@ -2665,7 +2665,7 @@
           <p:cNvPr id="16" name="">
             <a:extLst xmlns:a="http://schemas.openxmlformats.org/drawingml/2006/main">
               <a:ext uri="{FF2B5EF4-FFF2-40B4-BE49-F238E27FC236}">
-                <a16:creationId xmlns:a16="http://schemas.microsoft.com/office/drawing/2014/main" id="{B1A576A3-FB32-49A0-964D-77ACD42AA9CE}"/>
+                <a16:creationId xmlns:a16="http://schemas.microsoft.com/office/drawing/2014/main" id="{929C04C8-9BE2-4ADC-BC1A-A354700BE3E1}"/>
               </a:ext>
             </a:extLst>
           </p:cNvPr>
@@ -2722,7 +2722,7 @@
           <p:cNvPr id="17" name="">
             <a:extLst xmlns:a="http://schemas.openxmlformats.org/drawingml/2006/main">
               <a:ext uri="{FF2B5EF4-FFF2-40B4-BE49-F238E27FC236}">
-                <a16:creationId xmlns:a16="http://schemas.microsoft.com/office/drawing/2014/main" id="{E14A6F62-1827-49A3-A97F-444D22395DA0}"/>
+                <a16:creationId xmlns:a16="http://schemas.microsoft.com/office/drawing/2014/main" id="{8AC133F5-BAF7-43FA-97BE-E87C0AE4CF2A}"/>
               </a:ext>
             </a:extLst>
           </p:cNvPr>
@@ -2779,7 +2779,7 @@
           <p:cNvPr id="18" name="">
             <a:extLst xmlns:a="http://schemas.openxmlformats.org/drawingml/2006/main">
               <a:ext uri="{FF2B5EF4-FFF2-40B4-BE49-F238E27FC236}">
-                <a16:creationId xmlns:a16="http://schemas.microsoft.com/office/drawing/2014/main" id="{E64FB2AE-B8FA-44A6-8898-E926A3E95F0B}"/>
+                <a16:creationId xmlns:a16="http://schemas.microsoft.com/office/drawing/2014/main" id="{3C77A889-3978-4313-AAE0-981A142DD5DE}"/>
               </a:ext>
             </a:extLst>
           </p:cNvPr>
@@ -2834,7 +2834,7 @@
     </p:spTree>
     <p:extLst>
       <p:ext uri="{BB962C8B-B14F-4D97-AF65-F5344CB8AC3E}">
-        <p14:creationId xmlns:p14="http://schemas.microsoft.com/office/powerpoint/2010/main" val="1708240104"/>
+        <p14:creationId xmlns:p14="http://schemas.microsoft.com/office/powerpoint/2010/main" val="1258472250"/>
       </p:ext>
     </p:extLst>
   </p:cSld>
@@ -2865,7 +2865,7 @@
           <p:cNvPr id="13" name="">
             <a:extLst xmlns:a="http://schemas.openxmlformats.org/drawingml/2006/main">
               <a:ext uri="{FF2B5EF4-FFF2-40B4-BE49-F238E27FC236}">
-                <a16:creationId xmlns:a16="http://schemas.microsoft.com/office/drawing/2014/main" id="{677E86D8-5E19-4BAF-9C45-3288BA750BEA}"/>
+                <a16:creationId xmlns:a16="http://schemas.microsoft.com/office/drawing/2014/main" id="{CD0001F9-F72F-46CF-8620-A513AC883126}"/>
               </a:ext>
             </a:extLst>
           </p:cNvPr>
@@ -2922,7 +2922,7 @@
           <p:cNvPr id="2" name="">
             <a:extLst xmlns:a="http://schemas.openxmlformats.org/drawingml/2006/main">
               <a:ext uri="{FF2B5EF4-FFF2-40B4-BE49-F238E27FC236}">
-                <a16:creationId xmlns:a16="http://schemas.microsoft.com/office/drawing/2014/main" id="{57EE6CDB-A0D5-427E-A830-58357EA607EF}"/>
+                <a16:creationId xmlns:a16="http://schemas.microsoft.com/office/drawing/2014/main" id="{376967F9-155C-48EE-BB9A-572EB263B80C}"/>
               </a:ext>
             </a:extLst>
           </p:cNvPr>
@@ -2979,7 +2979,7 @@
           <p:cNvPr id="3" name="">
             <a:extLst xmlns:a="http://schemas.openxmlformats.org/drawingml/2006/main">
               <a:ext uri="{FF2B5EF4-FFF2-40B4-BE49-F238E27FC236}">
-                <a16:creationId xmlns:a16="http://schemas.microsoft.com/office/drawing/2014/main" id="{51501353-3C36-4559-BC93-2681C5D45CD3}"/>
+                <a16:creationId xmlns:a16="http://schemas.microsoft.com/office/drawing/2014/main" id="{11079181-076E-422B-9A1F-85D513B02429}"/>
               </a:ext>
             </a:extLst>
           </p:cNvPr>
@@ -3036,7 +3036,7 @@
           <p:cNvPr id="4" name="">
             <a:extLst xmlns:a="http://schemas.openxmlformats.org/drawingml/2006/main">
               <a:ext uri="{FF2B5EF4-FFF2-40B4-BE49-F238E27FC236}">
-                <a16:creationId xmlns:a16="http://schemas.microsoft.com/office/drawing/2014/main" id="{3E941D2A-34A5-45BF-9988-BC9FE662C386}"/>
+                <a16:creationId xmlns:a16="http://schemas.microsoft.com/office/drawing/2014/main" id="{83BE52E1-14CD-4ECD-AF71-B81643B22E9E}"/>
               </a:ext>
             </a:extLst>
           </p:cNvPr>
@@ -3083,7 +3083,7 @@
                 <a:ea typeface="Arial"/>
                 <a:cs typeface="Arial"/>
               </a:rPr>
-              <a:t>Opening received · shop flow incomplete</a:t>
+              <a:t>A real shop rehearsal completed on this laptop</a:t>
             </a:r>
           </a:p>
         </p:txBody>
@@ -3093,7 +3093,7 @@
           <p:cNvPr id="5" name="">
             <a:extLst xmlns:a="http://schemas.openxmlformats.org/drawingml/2006/main">
               <a:ext uri="{FF2B5EF4-FFF2-40B4-BE49-F238E27FC236}">
-                <a16:creationId xmlns:a16="http://schemas.microsoft.com/office/drawing/2014/main" id="{A5F49E45-9260-4624-A32B-1E58F4E42BD7}"/>
+                <a16:creationId xmlns:a16="http://schemas.microsoft.com/office/drawing/2014/main" id="{45D1BF5F-821F-4E72-903D-643BFD72F5A2}"/>
               </a:ext>
             </a:extLst>
           </p:cNvPr>
@@ -3150,7 +3150,7 @@
           <p:cNvPr id="6" name="">
             <a:extLst xmlns:a="http://schemas.openxmlformats.org/drawingml/2006/main">
               <a:ext uri="{FF2B5EF4-FFF2-40B4-BE49-F238E27FC236}">
-                <a16:creationId xmlns:a16="http://schemas.microsoft.com/office/drawing/2014/main" id="{DD3881BA-2A47-47D1-B375-D5F512F76BED}"/>
+                <a16:creationId xmlns:a16="http://schemas.microsoft.com/office/drawing/2014/main" id="{C1F921FD-A58B-460C-910B-988DC7391796}"/>
               </a:ext>
             </a:extLst>
           </p:cNvPr>
@@ -3230,7 +3230,7 @@
           <p:cNvPr id="7" name="">
             <a:extLst xmlns:a="http://schemas.openxmlformats.org/drawingml/2006/main">
               <a:ext uri="{FF2B5EF4-FFF2-40B4-BE49-F238E27FC236}">
-                <a16:creationId xmlns:a16="http://schemas.microsoft.com/office/drawing/2014/main" id="{947714B9-FC64-4783-AD76-608DCAB86045}"/>
+                <a16:creationId xmlns:a16="http://schemas.microsoft.com/office/drawing/2014/main" id="{7C00BEAA-E4DD-494A-9AE4-ACFB1069740D}"/>
               </a:ext>
             </a:extLst>
           </p:cNvPr>
@@ -3333,7 +3333,7 @@
           <p:cNvPr id="8" name="">
             <a:extLst xmlns:a="http://schemas.openxmlformats.org/drawingml/2006/main">
               <a:ext uri="{FF2B5EF4-FFF2-40B4-BE49-F238E27FC236}">
-                <a16:creationId xmlns:a16="http://schemas.microsoft.com/office/drawing/2014/main" id="{4A3E6363-7EC1-4111-AD61-5A96DEB6646F}"/>
+                <a16:creationId xmlns:a16="http://schemas.microsoft.com/office/drawing/2014/main" id="{D707430F-2747-46EF-AA9E-B165EABE7917}"/>
               </a:ext>
             </a:extLst>
           </p:cNvPr>
@@ -3390,7 +3390,7 @@
           <p:cNvPr id="9" name="">
             <a:extLst xmlns:a="http://schemas.openxmlformats.org/drawingml/2006/main">
               <a:ext uri="{FF2B5EF4-FFF2-40B4-BE49-F238E27FC236}">
-                <a16:creationId xmlns:a16="http://schemas.microsoft.com/office/drawing/2014/main" id="{305BB538-4269-43B4-AE24-038E1085D4B9}"/>
+                <a16:creationId xmlns:a16="http://schemas.microsoft.com/office/drawing/2014/main" id="{A8252E23-EF0C-4BA4-B050-1E377C0086AE}"/>
               </a:ext>
             </a:extLst>
           </p:cNvPr>
@@ -3470,7 +3470,7 @@
           <p:cNvPr id="10" name="">
             <a:extLst xmlns:a="http://schemas.openxmlformats.org/drawingml/2006/main">
               <a:ext uri="{FF2B5EF4-FFF2-40B4-BE49-F238E27FC236}">
-                <a16:creationId xmlns:a16="http://schemas.microsoft.com/office/drawing/2014/main" id="{B991AD14-6B2B-4BC5-B2A7-4131F6CD7649}"/>
+                <a16:creationId xmlns:a16="http://schemas.microsoft.com/office/drawing/2014/main" id="{9F1B9848-10EB-475E-83FA-805CD2EFA200}"/>
               </a:ext>
             </a:extLst>
           </p:cNvPr>
@@ -3573,7 +3573,7 @@
           <p:cNvPr id="11" name="">
             <a:extLst xmlns:a="http://schemas.openxmlformats.org/drawingml/2006/main">
               <a:ext uri="{FF2B5EF4-FFF2-40B4-BE49-F238E27FC236}">
-                <a16:creationId xmlns:a16="http://schemas.microsoft.com/office/drawing/2014/main" id="{5F7F2D01-1031-49C0-A2A0-18C6052CE18C}"/>
+                <a16:creationId xmlns:a16="http://schemas.microsoft.com/office/drawing/2014/main" id="{86C45B25-CCFE-40E4-B995-9840649BC8F9}"/>
               </a:ext>
             </a:extLst>
           </p:cNvPr>
@@ -3643,7 +3643,7 @@
                 <a:ea typeface="Arial"/>
                 <a:cs typeface="Arial"/>
               </a:rPr>
-              <a:t>The planned relay asks the customer, then returns the answer in Korean.</a:t>
+              <a:t>The live relay returned the answer in Korean and the call completed.</a:t>
             </a:r>
           </a:p>
         </p:txBody>
@@ -3653,7 +3653,7 @@
           <p:cNvPr id="12" name="">
             <a:extLst xmlns:a="http://schemas.openxmlformats.org/drawingml/2006/main">
               <a:ext uri="{FF2B5EF4-FFF2-40B4-BE49-F238E27FC236}">
-                <a16:creationId xmlns:a16="http://schemas.microsoft.com/office/drawing/2014/main" id="{1D1EDDF9-3079-4EE8-97A9-6238C1C96FC1}"/>
+                <a16:creationId xmlns:a16="http://schemas.microsoft.com/office/drawing/2014/main" id="{F3A1AF16-0B5D-43EC-A9FF-545BABE2FFFE}"/>
               </a:ext>
             </a:extLst>
           </p:cNvPr>
@@ -3708,7 +3708,7 @@
     </p:spTree>
     <p:extLst>
       <p:ext uri="{BB962C8B-B14F-4D97-AF65-F5344CB8AC3E}">
-        <p14:creationId xmlns:p14="http://schemas.microsoft.com/office/powerpoint/2010/main" val="2136494099"/>
+        <p14:creationId xmlns:p14="http://schemas.microsoft.com/office/powerpoint/2010/main" val="461601629"/>
       </p:ext>
     </p:extLst>
   </p:cSld>
@@ -3739,7 +3739,7 @@
           <p:cNvPr id="11" name="">
             <a:extLst xmlns:a="http://schemas.openxmlformats.org/drawingml/2006/main">
               <a:ext uri="{FF2B5EF4-FFF2-40B4-BE49-F238E27FC236}">
-                <a16:creationId xmlns:a16="http://schemas.microsoft.com/office/drawing/2014/main" id="{8AA3B214-2A8B-4395-AF53-9C5E87C1B58F}"/>
+                <a16:creationId xmlns:a16="http://schemas.microsoft.com/office/drawing/2014/main" id="{ECEED64D-9850-4C3A-8C65-4FFF17732F2B}"/>
               </a:ext>
             </a:extLst>
           </p:cNvPr>
@@ -3796,7 +3796,7 @@
           <p:cNvPr id="2" name="">
             <a:extLst xmlns:a="http://schemas.openxmlformats.org/drawingml/2006/main">
               <a:ext uri="{FF2B5EF4-FFF2-40B4-BE49-F238E27FC236}">
-                <a16:creationId xmlns:a16="http://schemas.microsoft.com/office/drawing/2014/main" id="{97F54962-0C4B-4509-841D-A0F521A90CA3}"/>
+                <a16:creationId xmlns:a16="http://schemas.microsoft.com/office/drawing/2014/main" id="{58C420A3-8816-4474-AC19-7E35542FB517}"/>
               </a:ext>
             </a:extLst>
           </p:cNvPr>
@@ -3853,7 +3853,7 @@
           <p:cNvPr id="3" name="">
             <a:extLst xmlns:a="http://schemas.openxmlformats.org/drawingml/2006/main">
               <a:ext uri="{FF2B5EF4-FFF2-40B4-BE49-F238E27FC236}">
-                <a16:creationId xmlns:a16="http://schemas.microsoft.com/office/drawing/2014/main" id="{2B782932-EF48-4387-83E9-9C49AC8E8A4D}"/>
+                <a16:creationId xmlns:a16="http://schemas.microsoft.com/office/drawing/2014/main" id="{08FA7000-DFD9-41C6-B6B0-3317F01272CE}"/>
               </a:ext>
             </a:extLst>
           </p:cNvPr>
@@ -3910,7 +3910,7 @@
           <p:cNvPr id="4" name="">
             <a:extLst xmlns:a="http://schemas.openxmlformats.org/drawingml/2006/main">
               <a:ext uri="{FF2B5EF4-FFF2-40B4-BE49-F238E27FC236}">
-                <a16:creationId xmlns:a16="http://schemas.microsoft.com/office/drawing/2014/main" id="{45CA7C13-B4B1-475B-ABFB-BEF74BCDDC77}"/>
+                <a16:creationId xmlns:a16="http://schemas.microsoft.com/office/drawing/2014/main" id="{6D8DE4BC-1C39-4145-8317-954A320B975C}"/>
               </a:ext>
             </a:extLst>
           </p:cNvPr>
@@ -3967,7 +3967,7 @@
           <p:cNvPr id="5" name="">
             <a:extLst xmlns:a="http://schemas.openxmlformats.org/drawingml/2006/main">
               <a:ext uri="{FF2B5EF4-FFF2-40B4-BE49-F238E27FC236}">
-                <a16:creationId xmlns:a16="http://schemas.microsoft.com/office/drawing/2014/main" id="{05A5CFEA-1AC9-4A76-89A5-19B0916A9C88}"/>
+                <a16:creationId xmlns:a16="http://schemas.microsoft.com/office/drawing/2014/main" id="{1122F517-C3EE-45CD-BF70-1436AC78844C}"/>
               </a:ext>
             </a:extLst>
           </p:cNvPr>
@@ -4014,7 +4014,7 @@
                 <a:ea typeface="Arial"/>
                 <a:cs typeface="Arial"/>
               </a:rPr>
-              <a:t>63 code + 23 HTTP checks passed. Mocked browser checks:</a:t>
+              <a:t>67 unit and 30 HTTP checks passed. Mocked browser checks:</a:t>
             </a:r>
           </a:p>
           <a:p xmlns:a="http://schemas.openxmlformats.org/drawingml/2006/main">
@@ -4037,7 +4037,7 @@
                 <a:ea typeface="Arial"/>
                 <a:cs typeface="Arial"/>
               </a:rPr>
-              <a:t>20 customer + 14 business checks passed.</a:t>
+              <a:t>20 customer, 19 business and 32 design checks passed.</a:t>
             </a:r>
           </a:p>
         </p:txBody>
@@ -4047,7 +4047,7 @@
           <p:cNvPr id="6" name="">
             <a:extLst xmlns:a="http://schemas.openxmlformats.org/drawingml/2006/main">
               <a:ext uri="{FF2B5EF4-FFF2-40B4-BE49-F238E27FC236}">
-                <a16:creationId xmlns:a16="http://schemas.microsoft.com/office/drawing/2014/main" id="{56205C77-B2D6-4B5D-BDC7-15D65177786A}"/>
+                <a16:creationId xmlns:a16="http://schemas.microsoft.com/office/drawing/2014/main" id="{CACFDDD8-9F5A-4B67-B9BB-D43381960063}"/>
               </a:ext>
             </a:extLst>
           </p:cNvPr>
@@ -4094,7 +4094,7 @@
                 <a:ea typeface="Arial"/>
                 <a:cs typeface="Arial"/>
               </a:rPr>
-              <a:t>HTTP setup plans are synthetic. These checks do not prove speech or value.</a:t>
+              <a:t>Automated checks are separate from the actual microphone rehearsal.</a:t>
             </a:r>
           </a:p>
         </p:txBody>
@@ -4104,7 +4104,7 @@
           <p:cNvPr id="7" name="">
             <a:extLst xmlns:a="http://schemas.openxmlformats.org/drawingml/2006/main">
               <a:ext uri="{FF2B5EF4-FFF2-40B4-BE49-F238E27FC236}">
-                <a16:creationId xmlns:a16="http://schemas.microsoft.com/office/drawing/2014/main" id="{EEAFDB05-4601-40A6-A298-8BD730B4E926}"/>
+                <a16:creationId xmlns:a16="http://schemas.microsoft.com/office/drawing/2014/main" id="{9BEAE10E-D0A5-46F9-B039-170738DD78CD}"/>
               </a:ext>
             </a:extLst>
           </p:cNvPr>
@@ -4151,7 +4151,7 @@
                 <a:ea typeface="Arial"/>
                 <a:cs typeface="Arial"/>
               </a:rPr>
-              <a:t>Latest shop voice attempt: Partial</a:t>
+              <a:t>Latest shop voice attempt: Completed</a:t>
             </a:r>
           </a:p>
         </p:txBody>
@@ -4161,7 +4161,7 @@
           <p:cNvPr id="8" name="">
             <a:extLst xmlns:a="http://schemas.openxmlformats.org/drawingml/2006/main">
               <a:ext uri="{FF2B5EF4-FFF2-40B4-BE49-F238E27FC236}">
-                <a16:creationId xmlns:a16="http://schemas.microsoft.com/office/drawing/2014/main" id="{DCE41109-2354-4547-AD7A-54358F077CBC}"/>
+                <a16:creationId xmlns:a16="http://schemas.microsoft.com/office/drawing/2014/main" id="{153E67D6-F7EC-4423-AA06-BC790B7CE593}"/>
               </a:ext>
             </a:extLst>
           </p:cNvPr>
@@ -4208,7 +4208,7 @@
                 <a:ea typeface="Arial"/>
                 <a:cs typeface="Arial"/>
               </a:rPr>
-              <a:t>Korean opening received; human audibility not confirmed.</a:t>
+              <a:t>Offered black instead of navy → customer accepted in chat.</a:t>
             </a:r>
           </a:p>
           <a:p xmlns:a="http://schemas.openxmlformats.org/drawingml/2006/main">
@@ -4231,7 +4231,7 @@
                 <a:ea typeface="Arial"/>
                 <a:cs typeface="Arial"/>
               </a:rPr>
-              <a:t>Stock and price were wrongly inferred; mic stalled, operator ended.</a:t>
+              <a:t>Korean return → ₩10,000 → pickup by 7 PM → confirmed ending.</a:t>
             </a:r>
           </a:p>
         </p:txBody>
@@ -4241,7 +4241,7 @@
           <p:cNvPr id="9" name="">
             <a:extLst xmlns:a="http://schemas.openxmlformats.org/drawingml/2006/main">
               <a:ext uri="{FF2B5EF4-FFF2-40B4-BE49-F238E27FC236}">
-                <a16:creationId xmlns:a16="http://schemas.microsoft.com/office/drawing/2014/main" id="{FFB03FF8-06E9-40CE-A965-A9C85DE71884}"/>
+                <a16:creationId xmlns:a16="http://schemas.microsoft.com/office/drawing/2014/main" id="{3EFA6CF8-5FF8-4B60-901C-BFE5D0BC0E48}"/>
               </a:ext>
             </a:extLst>
           </p:cNvPr>
@@ -4288,7 +4288,7 @@
                 <a:ea typeface="Arial"/>
                 <a:cs typeface="Arial"/>
               </a:rPr>
-              <a:t>Text replay passed; live repeat pending</a:t>
+              <a:t>Real microphone flow observed</a:t>
             </a:r>
           </a:p>
         </p:txBody>
@@ -4298,7 +4298,7 @@
           <p:cNvPr id="10" name="">
             <a:extLst xmlns:a="http://schemas.openxmlformats.org/drawingml/2006/main">
               <a:ext uri="{FF2B5EF4-FFF2-40B4-BE49-F238E27FC236}">
-                <a16:creationId xmlns:a16="http://schemas.microsoft.com/office/drawing/2014/main" id="{045CC994-B281-4998-B55E-3E0FA52E9847}"/>
+                <a16:creationId xmlns:a16="http://schemas.microsoft.com/office/drawing/2014/main" id="{57B7007C-AE8F-4A7F-83EB-AED77A720950}"/>
               </a:ext>
             </a:extLst>
           </p:cNvPr>
@@ -4345,7 +4345,7 @@
                 <a:ea typeface="Arial"/>
                 <a:cs typeface="Arial"/>
               </a:rPr>
-              <a:t>Recorded-text advice: 9/9 checks with one real API request.</a:t>
+              <a:t>The teammate confirmed Korean audio and microphone shutdown.</a:t>
             </a:r>
           </a:p>
           <a:p xmlns:a="http://schemas.openxmlformats.org/drawingml/2006/main">
@@ -4368,7 +4368,7 @@
                 <a:ea typeface="Arial"/>
                 <a:cs typeface="Arial"/>
               </a:rPr>
-              <a:t>Shop audibility, live relay and normal completion: Unverified.</a:t>
+              <a:t>One price fragment needed clarification. User value is unverified.</a:t>
             </a:r>
           </a:p>
         </p:txBody>
@@ -4376,7 +4376,7 @@
     </p:spTree>
     <p:extLst>
       <p:ext uri="{BB962C8B-B14F-4D97-AF65-F5344CB8AC3E}">
-        <p14:creationId xmlns:p14="http://schemas.microsoft.com/office/powerpoint/2010/main" val="1538490241"/>
+        <p14:creationId xmlns:p14="http://schemas.microsoft.com/office/powerpoint/2010/main" val="592779751"/>
       </p:ext>
     </p:extLst>
   </p:cSld>
@@ -4407,7 +4407,7 @@
           <p:cNvPr id="9" name="">
             <a:extLst xmlns:a="http://schemas.openxmlformats.org/drawingml/2006/main">
               <a:ext uri="{FF2B5EF4-FFF2-40B4-BE49-F238E27FC236}">
-                <a16:creationId xmlns:a16="http://schemas.microsoft.com/office/drawing/2014/main" id="{693AB2E7-1F08-4C0E-BEA6-177D80B5983C}"/>
+                <a16:creationId xmlns:a16="http://schemas.microsoft.com/office/drawing/2014/main" id="{8B4CAAE1-A139-44C2-B9C7-1EDAC1BFDFC8}"/>
               </a:ext>
             </a:extLst>
           </p:cNvPr>
@@ -4464,7 +4464,7 @@
           <p:cNvPr id="2" name="">
             <a:extLst xmlns:a="http://schemas.openxmlformats.org/drawingml/2006/main">
               <a:ext uri="{FF2B5EF4-FFF2-40B4-BE49-F238E27FC236}">
-                <a16:creationId xmlns:a16="http://schemas.microsoft.com/office/drawing/2014/main" id="{1C1E8B29-8404-4A3E-94C6-ECC618E7A9BA}"/>
+                <a16:creationId xmlns:a16="http://schemas.microsoft.com/office/drawing/2014/main" id="{78EFDEB0-E023-4098-91A2-63445FE2520F}"/>
               </a:ext>
             </a:extLst>
           </p:cNvPr>
@@ -4521,7 +4521,7 @@
           <p:cNvPr id="3" name="">
             <a:extLst xmlns:a="http://schemas.openxmlformats.org/drawingml/2006/main">
               <a:ext uri="{FF2B5EF4-FFF2-40B4-BE49-F238E27FC236}">
-                <a16:creationId xmlns:a16="http://schemas.microsoft.com/office/drawing/2014/main" id="{3B0E42DF-2E46-415D-BE73-145B06A26744}"/>
+                <a16:creationId xmlns:a16="http://schemas.microsoft.com/office/drawing/2014/main" id="{C5E5034A-D3C1-4359-81E1-5C50BEE06343}"/>
               </a:ext>
             </a:extLst>
           </p:cNvPr>
@@ -4578,7 +4578,7 @@
           <p:cNvPr id="4" name="">
             <a:extLst xmlns:a="http://schemas.openxmlformats.org/drawingml/2006/main">
               <a:ext uri="{FF2B5EF4-FFF2-40B4-BE49-F238E27FC236}">
-                <a16:creationId xmlns:a16="http://schemas.microsoft.com/office/drawing/2014/main" id="{C95E0430-544F-4583-A262-4384AC1B7B04}"/>
+                <a16:creationId xmlns:a16="http://schemas.microsoft.com/office/drawing/2014/main" id="{B87A34DD-DB87-4652-AFA0-84F66403123F}"/>
               </a:ext>
             </a:extLst>
           </p:cNvPr>
@@ -4658,7 +4658,7 @@
           <p:cNvPr id="5" name="">
             <a:extLst xmlns:a="http://schemas.openxmlformats.org/drawingml/2006/main">
               <a:ext uri="{FF2B5EF4-FFF2-40B4-BE49-F238E27FC236}">
-                <a16:creationId xmlns:a16="http://schemas.microsoft.com/office/drawing/2014/main" id="{B7997E78-C16E-4CD9-B8C0-0FF34109C488}"/>
+                <a16:creationId xmlns:a16="http://schemas.microsoft.com/office/drawing/2014/main" id="{C9286E87-F621-4E8A-9305-CD05B0351214}"/>
               </a:ext>
             </a:extLst>
           </p:cNvPr>
@@ -4715,7 +4715,7 @@
           <p:cNvPr id="6" name="">
             <a:extLst xmlns:a="http://schemas.openxmlformats.org/drawingml/2006/main">
               <a:ext uri="{FF2B5EF4-FFF2-40B4-BE49-F238E27FC236}">
-                <a16:creationId xmlns:a16="http://schemas.microsoft.com/office/drawing/2014/main" id="{9B621BE3-BBEB-48E6-A627-5F4AD4FBAFA6}"/>
+                <a16:creationId xmlns:a16="http://schemas.microsoft.com/office/drawing/2014/main" id="{4302F309-3D57-4038-9A94-52C829986CA9}"/>
               </a:ext>
             </a:extLst>
           </p:cNvPr>
@@ -4772,7 +4772,7 @@
           <p:cNvPr id="7" name="">
             <a:extLst xmlns:a="http://schemas.openxmlformats.org/drawingml/2006/main">
               <a:ext uri="{FF2B5EF4-FFF2-40B4-BE49-F238E27FC236}">
-                <a16:creationId xmlns:a16="http://schemas.microsoft.com/office/drawing/2014/main" id="{4A4AE514-DD79-4160-A67A-9B82FACC9B6B}"/>
+                <a16:creationId xmlns:a16="http://schemas.microsoft.com/office/drawing/2014/main" id="{15D250BF-E7BB-41AE-A0EF-370278D2538B}"/>
               </a:ext>
             </a:extLst>
           </p:cNvPr>
@@ -4829,7 +4829,7 @@
           <p:cNvPr id="8" name="">
             <a:extLst xmlns:a="http://schemas.openxmlformats.org/drawingml/2006/main">
               <a:ext uri="{FF2B5EF4-FFF2-40B4-BE49-F238E27FC236}">
-                <a16:creationId xmlns:a16="http://schemas.microsoft.com/office/drawing/2014/main" id="{37E04880-F93C-432C-BDB6-CF8A56E0B8A0}"/>
+                <a16:creationId xmlns:a16="http://schemas.microsoft.com/office/drawing/2014/main" id="{1E504FA3-E22C-4A3B-8EE3-C180EA5E350D}"/>
               </a:ext>
             </a:extLst>
           </p:cNvPr>
@@ -4907,7 +4907,7 @@
     </p:spTree>
     <p:extLst>
       <p:ext uri="{BB962C8B-B14F-4D97-AF65-F5344CB8AC3E}">
-        <p14:creationId xmlns:p14="http://schemas.microsoft.com/office/powerpoint/2010/main" val="1294469842"/>
+        <p14:creationId xmlns:p14="http://schemas.microsoft.com/office/powerpoint/2010/main" val="765127978"/>
       </p:ext>
     </p:extLst>
   </p:cSld>

</xml_diff>